<commit_message>
PROYECTO: entrega_2_eda — actualizacion completa (notebook, informe, figuras, presentacion, resultados, scripts de figuras) [sesion paralela]
</commit_message>
<xml_diff>
--- a/PROYECTO/SEGUNDA ENTREGA/entrega_2_eda/presentacion/Entrega_2_Presentacion.pptx
+++ b/PROYECTO/SEGUNDA ENTREGA/entrega_2_eda/presentacion/Entrega_2_Presentacion.pptx
@@ -10,10 +10,12 @@
   <p:sldIdLst>
     <p:sldId id="256" r:id="rId4"/>
     <p:sldId id="257" r:id="rId5"/>
+    <p:sldId id="292" r:id="rId44"/>
     <p:sldId id="278" r:id="rId30"/>
     <p:sldId id="279" r:id="rId31"/>
     <p:sldId id="280" r:id="rId32"/>
     <p:sldId id="281" r:id="rId33"/>
+    <p:sldId id="291" r:id="rId43"/>
     <p:sldId id="282" r:id="rId34"/>
     <p:sldId id="283" r:id="rId35"/>
     <p:sldId id="284" r:id="rId36"/>
@@ -22,6 +24,7 @@
     <p:sldId id="287" r:id="rId39"/>
     <p:sldId id="288" r:id="rId40"/>
     <p:sldId id="289" r:id="rId41"/>
+    <p:sldId id="293" r:id="rId45"/>
     <p:sldId id="290" r:id="rId42"/>
   </p:sldIdLst>
   <p:sldSz cx="12192000" cy="6858000"/>
@@ -1628,7 +1631,7 @@
           <a:lstStyle/>
           <a:p>
             <a:r>
-              <a:t>La ruta de la presentacion: resumen de la Entrega 1, estado del arte, el trabajo de la Entrega 2 y las conclusiones con el trabajo futuro.</a:t>
+              <a:t>La ruta de la presentacion: objetivo del proyecto, resumen de la Entrega 1, estado del arte, la metodologia de trabajo, el trabajo de la Entrega 2, los trabajos futuros y las conclusiones.</a:t>
             </a:r>
           </a:p>
         </p:txBody>
@@ -1737,7 +1740,7 @@
           <a:lstStyle/>
           <a:p>
             <a:r>
-              <a:t>Sintesis de la Entrega 1: el corpus se depuro desde 23.750 registros crudos; la extraccion por expresiones regulares logro 99,97 % de eficacia; se excluyeron 8 filas (6 autos y 2 HTML) y quedaron 23.742 sentencias con una muestra estratificada de 25 documentos para inspeccion.</a:t>
+              <a:t>El objetivo general del proyecto es un sistema de apoyo al analisis y la consulta de la jurisprudencia constitucional, con cuatro componentes: validar la providencia, clasificar su area tematica, identificar los articulos de la Constitucion que la sustentan y situarla en su contexto jurisprudencial. Esta entrega avanza en el corpus caracterizado y medido, la representacion y la metodologia de clasificacion; el vinculo con los articulos y el contexto jurisprudencial se plantean como trabajo futuro.</a:t>
             </a:r>
           </a:p>
         </p:txBody>
@@ -1807,7 +1810,7 @@
           <a:lstStyle/>
           <a:p>
             <a:r>
-              <a:t>La limpieza en ocho pasos normalizo el texto (minusculas, NFD, preservacion de la ene, filtro de ruido y 306 stopwords normalizadas). La textometria basica midio 260,99 millones de palabras crudas, 250,01 millones de tokens normalizados y 128,81 millones de tokens sin stopwords: las sentencias son documentos muy extensos y formulaicos.</a:t>
+              <a:t>Sintesis de la Entrega 1: el corpus se depuro desde 23.750 registros crudos; la extraccion por expresiones regulares logro 99,97 % de eficacia; se excluyeron 8 filas (6 autos y 2 HTML) y quedaron 23.742 sentencias con una muestra estratificada de 25 documentos para inspeccion.</a:t>
             </a:r>
           </a:p>
         </p:txBody>
@@ -1877,7 +1880,7 @@
           <a:lstStyle/>
           <a:p>
             <a:r>
-              <a:t>El estado del arte de esta entrega se apoya en el trabajo sobre el mismo corpus, la evidencia de que el preprocesamiento importa y los antecedentes de clasificacion de sentencias largas y en espanol.</a:t>
+              <a:t>La limpieza en ocho pasos normalizo el texto (minusculas, NFD, preservacion de la ene, filtro de ruido y 306 stopwords normalizadas). La textometria basica midio 260,99 millones de palabras crudas, 250,01 millones de tokens normalizados y 128,81 millones de tokens sin stopwords: las sentencias son documentos muy extensos y formulaicos.</a:t>
             </a:r>
           </a:p>
         </p:txBody>
@@ -1947,7 +1950,7 @@
           <a:lstStyle/>
           <a:p>
             <a:r>
-              <a:t>Para la representacion y la diacronia nos apoyamos en los fundamentos de recuperacion de informacion, la razon de verosimilitud, la MTLD, el log-odds y los modelos contextuales en espanol y de dominio legal.</a:t>
+              <a:t>El estado del arte de esta entrega se apoya en el trabajo sobre el mismo corpus, la evidencia de que el preprocesamiento importa y los antecedentes de clasificacion de sentencias largas y en espanol.</a:t>
             </a:r>
           </a:p>
         </p:txBody>
@@ -2017,7 +2020,7 @@
           <a:lstStyle/>
           <a:p>
             <a:r>
-              <a:t>Respecto a la Entrega 1 no hay rectificaciones de cifras: los cambios son extensiones verificadas, del dataset medido al EDA extendido, la unidad validada, la diacronia y la representacion con la propuesta metodologica.</a:t>
+              <a:t>Para la representacion y la diacronia nos apoyamos en los fundamentos de recuperacion de informacion, la razon de verosimilitud, la MTLD, el log-odds y los modelos contextuales en espanol y de dominio legal.</a:t>
             </a:r>
           </a:p>
         </p:txBody>
@@ -2087,7 +2090,7 @@
           <a:lstStyle/>
           <a:p>
             <a:r>
-              <a:t>El requisito 3 se cumple con un parquet de 23.742 filas por 12 columnas, verificado con aserciones duras: sin nulos, ids unicos y sumas reconciliadas con las cifras canonicas. Se adjuntan muestra estratificada, diccionario de datos y lemas por documento.</a:t>
+              <a:t>Además de los resultados, la entrega documenta el método de trabajo: un proceso por fases con puertas de calidad (comprensión de datos, preparación, análisis y representación), reproducibilidad de punta a punta (limpieza por etapas, semilla fija 42 y análisis ejecutado y sellado) y control de calidad con revisiones y auditorías que recomputan las cifras. El modelado es la siguiente fase.</a:t>
             </a:r>
           </a:p>
         </p:txBody>
@@ -2157,7 +2160,7 @@
           <a:lstStyle/>
           <a:p>
             <a:r>
-              <a:t>El corpus es fuertemente formulaico: accion de tutela domina y la validacion manual de 20 colocaciones da 75 por ciento de formulas validas con la razon de verosimilitud, frente a 55 por ciento de la frecuencia y 0 por ciento del PMI.</a:t>
+              <a:t>Respecto a la Entrega 1 no hay rectificaciones de cifras: los cambios son extensiones verificadas, del dataset medido al EDA extendido, la unidad validada, la diacronia y la representacion con la propuesta metodologica.</a:t>
             </a:r>
           </a:p>
         </p:txBody>
@@ -2227,7 +2230,7 @@
           <a:lstStyle/>
           <a:p>
             <a:r>
-              <a:t>La diversidad lexica desciende de forma sostenida en las tres decadas y la lematizacion reduce el vocabulario conservando la legibilidad: es la base de la representacion TF-IDF.</a:t>
+              <a:t>El requisito 3 se cumple con un conjunto de datos medido de 23.742 filas por 12 columnas, verificado con aserciones duras: sin nulos, ids unicos y sumas reconciliadas con las cifras canonicas. Se adjuntan muestra estratificada, diccionario de datos y lemas por documento.</a:t>
             </a:r>
           </a:p>
         </p:txBody>
@@ -2297,7 +2300,7 @@
           <a:lstStyle/>
           <a:p>
             <a:r>
-              <a:t>El contraste por periodos cumple la promesa de la Entrega 1: en la ultima decada gana peso el vocabulario del conflicto armado y la pandemia. Los extremos incluyen siglas y ruido de OCR; el metodo es fiel a la referencia interna y se reporta el limite.</a:t>
+              <a:t>El corpus es fuertemente formulaico: accion de tutela domina y el 82,7 por ciento de los trigramas guardados son formulas; la validacion manual de 20 colocaciones favorecio la razon de verosimilitud (75 por ciento de formulas validas frente a 55 por ciento de la frecuencia y 0 por ciento del PMI). El espectro de frecuencias confirma la concentracion del vocabulario: un tercio de los tipos son hapax y el 4,4 por ciento de los tipos concentra el 93,5 por ciento de los tokens.</a:t>
             </a:r>
           </a:p>
         </p:txBody>
@@ -2367,7 +2370,7 @@
           <a:lstStyle/>
           <a:p>
             <a:r>
-              <a:t>Ninguna ontologia internacional cubre el espanol juridico colombiano: se evaluaron cuatro candidatas y se decidio derivar una taxonomia ligera de la propia Constitucion Politica.</a:t>
+              <a:t>La diversidad lexica desciende de forma sostenida en las tres decadas y la lematizacion reduce el vocabulario conservando la legibilidad: es la base de la representacion TF-IDF.</a:t>
             </a:r>
           </a:p>
         </p:txBody>
@@ -2437,7 +2440,7 @@
           <a:lstStyle/>
           <a:p>
             <a:r>
-              <a:t>La representacion principal es TF-IDF sobre lemas: interpretable, de bajo costo y con 95,66 por ciento de esparsidad. Los embeddings contextuales se evaluaron como comparacion: capturan cercania semantica con mayor costo.</a:t>
+              <a:t>El contraste por periodos cumple la promesa de la Entrega 1: en la ultima decada gana peso el vocabulario del conflicto armado y la pandemia. Los extremos incluyen siglas y ruido de OCR; el metodo es fiel a la referencia interna y se reporta el limite.</a:t>
             </a:r>
           </a:p>
         </p:txBody>
@@ -2507,7 +2510,7 @@
           <a:lstStyle/>
           <a:p>
             <a:r>
-              <a:t>La propuesta define la tarea, las particiones con prueba intocable, los modelos a comparar y los criterios: macro-F1, analisis de errores y costo. Sin resultados de modelos: es una propuesta metodologica.</a:t>
+              <a:t>Ninguna ontologia internacional cubre el espanol juridico colombiano: se evaluaron cuatro candidatas y se decidio derivar una taxonomia ligera de la propia Constitucion Politica.</a:t>
             </a:r>
           </a:p>
         </p:txBody>
@@ -2533,6 +2536,216 @@
 </file>
 
 <file path=ppt/notesSlides/notesSlide35.xml><?xml version="1.0" encoding="utf-8"?>
+<p:notes xmlns:a="http://schemas.openxmlformats.org/drawingml/2006/main" xmlns:p="http://schemas.openxmlformats.org/presentationml/2006/main" xmlns:r="http://schemas.openxmlformats.org/officeDocument/2006/relationships">
+  <p:cSld>
+    <p:spTree>
+      <p:nvGrpSpPr>
+        <p:cNvPr id="1" name=""/>
+        <p:cNvGrpSpPr/>
+        <p:nvPr/>
+      </p:nvGrpSpPr>
+      <p:grpSpPr>
+        <a:xfrm>
+          <a:off x="0" y="0"/>
+          <a:ext cx="0" cy="0"/>
+          <a:chOff x="0" y="0"/>
+          <a:chExt cx="0" cy="0"/>
+        </a:xfrm>
+      </p:grpSpPr>
+      <p:sp>
+        <p:nvSpPr>
+          <p:cNvPr id="2" name="Slide Image Placeholder 1"/>
+          <p:cNvSpPr>
+            <a:spLocks noGrp="1"/>
+          </p:cNvSpPr>
+          <p:nvPr>
+            <p:ph type="sldImg" idx="3"/>
+          </p:nvPr>
+        </p:nvSpPr>
+        <p:spPr/>
+      </p:sp>
+      <p:sp>
+        <p:nvSpPr>
+          <p:cNvPr id="3" name="Notes Placeholder 2"/>
+          <p:cNvSpPr>
+            <a:spLocks noGrp="1"/>
+          </p:cNvSpPr>
+          <p:nvPr>
+            <p:ph type="body" idx="1"/>
+          </p:nvPr>
+        </p:nvSpPr>
+        <p:spPr/>
+        <p:txBody>
+          <a:bodyPr/>
+          <a:lstStyle/>
+          <a:p>
+            <a:r>
+              <a:t>La representacion principal es TF-IDF sobre lemas: interpretable, de bajo costo y con 95,66 por ciento de esparsidad. Casi todos los documentos (99,95 por ciento) exceden la ventana de 512 tokens de los modelos contextuales, que exigiran segmentacion; TF-IDF, que representa el documento completo, queda como base de la fase de modelado.</a:t>
+            </a:r>
+          </a:p>
+        </p:txBody>
+      </p:sp>
+      <p:sp>
+        <p:nvSpPr>
+          <p:cNvPr id="4" name="Slide Number Placeholder 3"/>
+          <p:cNvSpPr>
+            <a:spLocks noGrp="1"/>
+          </p:cNvSpPr>
+          <p:nvPr>
+            <p:ph type="sldNum" idx="12"/>
+          </p:nvPr>
+        </p:nvSpPr>
+        <p:spPr/>
+      </p:sp>
+    </p:spTree>
+  </p:cSld>
+  <p:clrMapOvr>
+    <a:masterClrMapping/>
+  </p:clrMapOvr>
+</p:notes>
+</file>
+
+<file path=ppt/notesSlides/notesSlide36.xml><?xml version="1.0" encoding="utf-8"?>
+<p:notes xmlns:a="http://schemas.openxmlformats.org/drawingml/2006/main" xmlns:p="http://schemas.openxmlformats.org/presentationml/2006/main" xmlns:r="http://schemas.openxmlformats.org/officeDocument/2006/relationships">
+  <p:cSld>
+    <p:spTree>
+      <p:nvGrpSpPr>
+        <p:cNvPr id="1" name=""/>
+        <p:cNvGrpSpPr/>
+        <p:nvPr/>
+      </p:nvGrpSpPr>
+      <p:grpSpPr>
+        <a:xfrm>
+          <a:off x="0" y="0"/>
+          <a:ext cx="0" cy="0"/>
+          <a:chOff x="0" y="0"/>
+          <a:chExt cx="0" cy="0"/>
+        </a:xfrm>
+      </p:grpSpPr>
+      <p:sp>
+        <p:nvSpPr>
+          <p:cNvPr id="2" name="Slide Image Placeholder 1"/>
+          <p:cNvSpPr>
+            <a:spLocks noGrp="1"/>
+          </p:cNvSpPr>
+          <p:nvPr>
+            <p:ph type="sldImg" idx="3"/>
+          </p:nvPr>
+        </p:nvSpPr>
+        <p:spPr/>
+      </p:sp>
+      <p:sp>
+        <p:nvSpPr>
+          <p:cNvPr id="3" name="Notes Placeholder 2"/>
+          <p:cNvSpPr>
+            <a:spLocks noGrp="1"/>
+          </p:cNvSpPr>
+          <p:nvPr>
+            <p:ph type="body" idx="1"/>
+          </p:nvPr>
+        </p:nvSpPr>
+        <p:spPr/>
+        <p:txBody>
+          <a:bodyPr/>
+          <a:lstStyle/>
+          <a:p>
+            <a:r>
+              <a:t>La propuesta define la tarea, las particiones con prueba intocable, los modelos a comparar y los criterios: macro-F1, analisis de errores y costo. Sin resultados de modelos: es una propuesta metodologica.</a:t>
+            </a:r>
+          </a:p>
+        </p:txBody>
+      </p:sp>
+      <p:sp>
+        <p:nvSpPr>
+          <p:cNvPr id="4" name="Slide Number Placeholder 3"/>
+          <p:cNvSpPr>
+            <a:spLocks noGrp="1"/>
+          </p:cNvSpPr>
+          <p:nvPr>
+            <p:ph type="sldNum" idx="12"/>
+          </p:nvPr>
+        </p:nvSpPr>
+        <p:spPr/>
+      </p:sp>
+    </p:spTree>
+  </p:cSld>
+  <p:clrMapOvr>
+    <a:masterClrMapping/>
+  </p:clrMapOvr>
+</p:notes>
+</file>
+
+<file path=ppt/notesSlides/notesSlide37.xml><?xml version="1.0" encoding="utf-8"?>
+<p:notes xmlns:a="http://schemas.openxmlformats.org/drawingml/2006/main" xmlns:p="http://schemas.openxmlformats.org/presentationml/2006/main" xmlns:r="http://schemas.openxmlformats.org/officeDocument/2006/relationships">
+  <p:cSld>
+    <p:spTree>
+      <p:nvGrpSpPr>
+        <p:cNvPr id="1" name=""/>
+        <p:cNvGrpSpPr/>
+        <p:nvPr/>
+      </p:nvGrpSpPr>
+      <p:grpSpPr>
+        <a:xfrm>
+          <a:off x="0" y="0"/>
+          <a:ext cx="0" cy="0"/>
+          <a:chOff x="0" y="0"/>
+          <a:chExt cx="0" cy="0"/>
+        </a:xfrm>
+      </p:grpSpPr>
+      <p:sp>
+        <p:nvSpPr>
+          <p:cNvPr id="2" name="Slide Image Placeholder 1"/>
+          <p:cNvSpPr>
+            <a:spLocks noGrp="1"/>
+          </p:cNvSpPr>
+          <p:nvPr>
+            <p:ph type="sldImg" idx="3"/>
+          </p:nvPr>
+        </p:nvSpPr>
+        <p:spPr/>
+      </p:sp>
+      <p:sp>
+        <p:nvSpPr>
+          <p:cNvPr id="3" name="Notes Placeholder 2"/>
+          <p:cNvSpPr>
+            <a:spLocks noGrp="1"/>
+          </p:cNvSpPr>
+          <p:nvPr>
+            <p:ph type="body" idx="1"/>
+          </p:nvPr>
+        </p:nvSpPr>
+        <p:spPr/>
+        <p:txBody>
+          <a:bodyPr/>
+          <a:lstStyle/>
+          <a:p>
+            <a:r>
+              <a:t>El trabajo posterior se plantea como continuidad de lo construido, con herramientas concretas por etapa. Etiquetas: etiquetado debil por citas a la Constitucion y tesauro EuroVoc, auditoria de ruido con cleanlab, preanotacion con ALIA-7B-Instruct y validacion humana progresiva. Modelado supervisado: TF-IDF con regresion logistica y SVM lineal (scikit-learn), LightGBM y ajuste eficiente con LoRA/PEFT. Recuperacion: busqueda hibrida BM25 mas embeddings E5, reranker cross-encoder y ALIA-7B-Instruct, con el grafo de citas como senal. Representaciones contextuales: multilingual-e5-base, BETO por documento y por fragmentos, y variantes legales evaluadas (ALIA-MrBERT, BGE-M3, ModernBERT legal). Aplicaciones: resumen y consulta con ALIA-7B-Instruct, contexto jurisprudencial con retrieval y grafo de citas, y diacronia con embeddings alineados. Varias de estas herramientas ya estan implementadas en el avance del proyecto, de modo que cada frente continua sobre componentes ya probados; no se reportan cifras de rendimiento: es trabajo en curso. El sustento es doble: el estado del arte respalda cada frente y los datos del corpus los justifican (99,95 por ciento de los documentos excede los 512 tokens; T concentra el 72,02 por ciento; el 97,17 por ciento de las sentencias tiene marcador tematico).</a:t>
+            </a:r>
+          </a:p>
+        </p:txBody>
+      </p:sp>
+      <p:sp>
+        <p:nvSpPr>
+          <p:cNvPr id="4" name="Slide Number Placeholder 3"/>
+          <p:cNvSpPr>
+            <a:spLocks noGrp="1"/>
+          </p:cNvSpPr>
+          <p:nvPr>
+            <p:ph type="sldNum" idx="12"/>
+          </p:nvPr>
+        </p:nvSpPr>
+        <p:spPr/>
+      </p:sp>
+    </p:spTree>
+  </p:cSld>
+  <p:clrMapOvr>
+    <a:masterClrMapping/>
+  </p:clrMapOvr>
+</p:notes>
+</file>
+
+<file path=ppt/notesSlides/notesSlide38.xml><?xml version="1.0" encoding="utf-8"?>
 <p:notes xmlns:a="http://schemas.openxmlformats.org/drawingml/2006/main" xmlns:p="http://schemas.openxmlformats.org/presentationml/2006/main" xmlns:r="http://schemas.openxmlformats.org/officeDocument/2006/relationships">
   <p:cSld>
     <p:spTree>
@@ -13013,7 +13226,7 @@
               <a:defRPr/>
             </a:pPr>
             <a:r>
-              <a:rPr lang="es-CO" sz="4800" b="1">
+              <a:rPr lang="es-CO" sz="4000" b="1">
                 <a:solidFill>
                   <a:schemeClr val="accent4">
                     <a:lumMod val="60000"/>
@@ -13023,7 +13236,32 @@
                 <a:latin typeface="Arial"/>
                 <a:cs typeface="Arial"/>
               </a:rPr>
-              <a:t>Análisis de sentencias de la Corte Constitucional de Colombia (1992-2021)</a:t>
+              <a:t>Análisis y clasificación automática de sentencias de la Corte Constitucional de Colombia</a:t>
+            </a:r>
+            <a:br>
+              <a:rPr lang="es-CO" sz="4000" b="1">
+                <a:solidFill>
+                  <a:schemeClr val="accent4">
+                    <a:lumMod val="60000"/>
+                    <a:lumOff val="40000"/>
+                  </a:schemeClr>
+                </a:solidFill>
+                <a:latin typeface="Arial"/>
+                <a:cs typeface="Arial"/>
+              </a:rPr>
+            </a:br>
+            <a:r>
+              <a:rPr lang="es-CO" sz="4000" b="1">
+                <a:solidFill>
+                  <a:schemeClr val="accent4">
+                    <a:lumMod val="60000"/>
+                    <a:lumOff val="40000"/>
+                  </a:schemeClr>
+                </a:solidFill>
+                <a:latin typeface="Arial"/>
+                <a:cs typeface="Arial"/>
+              </a:rPr>
+              <a:t>(1992-2021)</a:t>
             </a:r>
             <a:endParaRPr/>
           </a:p>
@@ -13355,8 +13593,8 @@
         </p:nvSpPr>
         <p:spPr bwMode="auto">
           <a:xfrm>
-            <a:off x="914400" y="2260600"/>
-            <a:ext cx="10363200" cy="812800"/>
+            <a:off x="914400" y="2231136"/>
+            <a:ext cx="10363200" cy="512064"/>
           </a:xfrm>
           <a:prstGeom prst="roundRect">
             <a:avLst>
@@ -13408,8 +13646,8 @@
         </p:nvSpPr>
         <p:spPr bwMode="auto">
           <a:xfrm>
-            <a:off x="1066800" y="2387600"/>
-            <a:ext cx="609600" cy="558800"/>
+            <a:off x="1066800" y="2276856"/>
+            <a:ext cx="609600" cy="420624"/>
           </a:xfrm>
           <a:prstGeom prst="roundRect">
             <a:avLst>
@@ -13469,8 +13707,8 @@
         </p:nvSpPr>
         <p:spPr bwMode="auto">
           <a:xfrm>
-            <a:off x="1905000" y="2362199"/>
-            <a:ext cx="7493000" cy="609600"/>
+            <a:off x="1905000" y="2240280"/>
+            <a:ext cx="7493000" cy="493776"/>
           </a:xfrm>
           <a:prstGeom prst="rect">
             <a:avLst/>
@@ -13492,7 +13730,7 @@
                   <a:srgbClr val="073654"/>
                 </a:solidFill>
               </a:rPr>
-              <a:t>Resumen de la Entrega 1</a:t>
+              <a:t>Objetivo del proyecto</a:t>
             </a:r>
             <a:br>
               <a:rPr lang="es-ES" sz="1200">
@@ -13507,7 +13745,7 @@
                   <a:srgbClr val="425466"/>
                 </a:solidFill>
               </a:rPr>
-              <a:t>Corpus, limpieza y textometría básica</a:t>
+              <a:t>General y objetivos específicos</a:t>
             </a:r>
             <a:endParaRPr lang="es-CO" sz="1200">
               <a:solidFill>
@@ -13525,8 +13763,8 @@
         </p:nvSpPr>
         <p:spPr bwMode="auto">
           <a:xfrm>
-            <a:off x="9906000" y="2413000"/>
-            <a:ext cx="1041400" cy="508000"/>
+            <a:off x="9906000" y="2286000"/>
+            <a:ext cx="1041400" cy="402336"/>
           </a:xfrm>
           <a:prstGeom prst="rect">
             <a:avLst/>
@@ -13548,7 +13786,7 @@
                   <a:srgbClr val="2F75B5"/>
                 </a:solidFill>
               </a:rPr>
-              <a:t>03–04</a:t>
+              <a:t>03</a:t>
             </a:r>
             <a:endParaRPr/>
           </a:p>
@@ -13562,8 +13800,8 @@
         </p:nvSpPr>
         <p:spPr bwMode="auto">
           <a:xfrm>
-            <a:off x="914400" y="3174390"/>
-            <a:ext cx="10363200" cy="812800"/>
+            <a:off x="914400" y="2798064"/>
+            <a:ext cx="10363200" cy="512064"/>
           </a:xfrm>
           <a:prstGeom prst="roundRect">
             <a:avLst>
@@ -13615,8 +13853,8 @@
         </p:nvSpPr>
         <p:spPr bwMode="auto">
           <a:xfrm>
-            <a:off x="1066800" y="3301390"/>
-            <a:ext cx="609600" cy="558800"/>
+            <a:off x="1066800" y="2843784"/>
+            <a:ext cx="609600" cy="420624"/>
           </a:xfrm>
           <a:prstGeom prst="roundRect">
             <a:avLst>
@@ -13676,8 +13914,8 @@
         </p:nvSpPr>
         <p:spPr bwMode="auto">
           <a:xfrm>
-            <a:off x="1905000" y="3275990"/>
-            <a:ext cx="7493000" cy="609600"/>
+            <a:off x="1905000" y="2807208"/>
+            <a:ext cx="7493000" cy="493776"/>
           </a:xfrm>
           <a:prstGeom prst="rect">
             <a:avLst/>
@@ -13699,7 +13937,7 @@
                   <a:srgbClr val="073654"/>
                 </a:solidFill>
               </a:rPr>
-              <a:t>Estado del arte</a:t>
+              <a:t>Resumen de la Entrega 1</a:t>
             </a:r>
             <a:br>
               <a:rPr lang="es-ES" sz="1200">
@@ -13714,7 +13952,7 @@
                   <a:srgbClr val="425466"/>
                 </a:solidFill>
               </a:rPr>
-              <a:t>Antecedentes y representación</a:t>
+              <a:t>Corpus, limpieza y textometría básica</a:t>
             </a:r>
             <a:endParaRPr lang="es-CO" sz="1200">
               <a:solidFill>
@@ -13732,8 +13970,8 @@
         </p:nvSpPr>
         <p:spPr bwMode="auto">
           <a:xfrm>
-            <a:off x="9906000" y="3326790"/>
-            <a:ext cx="1041400" cy="508000"/>
+            <a:off x="9906000" y="2852928"/>
+            <a:ext cx="1041400" cy="402336"/>
           </a:xfrm>
           <a:prstGeom prst="rect">
             <a:avLst/>
@@ -13755,7 +13993,7 @@
                   <a:srgbClr val="D99A00"/>
                 </a:solidFill>
               </a:rPr>
-              <a:t>05–06</a:t>
+              <a:t>04–05</a:t>
             </a:r>
             <a:endParaRPr/>
           </a:p>
@@ -13769,8 +14007,8 @@
         </p:nvSpPr>
         <p:spPr bwMode="auto">
           <a:xfrm>
-            <a:off x="914400" y="4089095"/>
-            <a:ext cx="10363200" cy="812800"/>
+            <a:off x="914400" y="3364991"/>
+            <a:ext cx="10363200" cy="512064"/>
           </a:xfrm>
           <a:prstGeom prst="roundRect">
             <a:avLst>
@@ -13822,8 +14060,8 @@
         </p:nvSpPr>
         <p:spPr bwMode="auto">
           <a:xfrm>
-            <a:off x="1066800" y="4216095"/>
-            <a:ext cx="609600" cy="558800"/>
+            <a:off x="1066800" y="3410711"/>
+            <a:ext cx="609600" cy="420624"/>
           </a:xfrm>
           <a:prstGeom prst="roundRect">
             <a:avLst>
@@ -13883,8 +14121,8 @@
         </p:nvSpPr>
         <p:spPr bwMode="auto">
           <a:xfrm>
-            <a:off x="1905000" y="4190695"/>
-            <a:ext cx="7493000" cy="609600"/>
+            <a:off x="1905000" y="3374135"/>
+            <a:ext cx="7493000" cy="493776"/>
           </a:xfrm>
           <a:prstGeom prst="rect">
             <a:avLst/>
@@ -13906,7 +14144,7 @@
                   <a:srgbClr val="073654"/>
                 </a:solidFill>
               </a:rPr>
-              <a:t>Corpus medido y EDA avanzado</a:t>
+              <a:t>Estado del arte</a:t>
             </a:r>
             <a:br>
               <a:rPr lang="es-ES" sz="1200">
@@ -13921,7 +14159,7 @@
                   <a:srgbClr val="425466"/>
                 </a:solidFill>
               </a:rPr>
-              <a:t>Dataset, n-gramas, diversidad y diacronía</a:t>
+              <a:t>Antecedentes y representación</a:t>
             </a:r>
             <a:endParaRPr lang="es-CO" sz="1200">
               <a:solidFill>
@@ -13939,8 +14177,8 @@
         </p:nvSpPr>
         <p:spPr bwMode="auto">
           <a:xfrm>
-            <a:off x="9906000" y="4241495"/>
-            <a:ext cx="1041400" cy="508000"/>
+            <a:off x="9906000" y="3419856"/>
+            <a:ext cx="1041400" cy="402336"/>
           </a:xfrm>
           <a:prstGeom prst="rect">
             <a:avLst/>
@@ -13962,7 +14200,7 @@
                   <a:srgbClr val="2E8B57"/>
                 </a:solidFill>
               </a:rPr>
-              <a:t>07–12</a:t>
+              <a:t>06–07</a:t>
             </a:r>
             <a:endParaRPr/>
           </a:p>
@@ -13976,8 +14214,8 @@
         </p:nvSpPr>
         <p:spPr bwMode="auto">
           <a:xfrm>
-            <a:off x="914400" y="5003800"/>
-            <a:ext cx="10363200" cy="812800"/>
+            <a:off x="914400" y="3931920"/>
+            <a:ext cx="10363200" cy="512064"/>
           </a:xfrm>
           <a:prstGeom prst="roundRect">
             <a:avLst>
@@ -14029,8 +14267,8 @@
         </p:nvSpPr>
         <p:spPr bwMode="auto">
           <a:xfrm>
-            <a:off x="1066800" y="5130800"/>
-            <a:ext cx="609600" cy="558800"/>
+            <a:off x="1066800" y="3977639"/>
+            <a:ext cx="609600" cy="420624"/>
           </a:xfrm>
           <a:prstGeom prst="roundRect">
             <a:avLst>
@@ -14090,8 +14328,8 @@
         </p:nvSpPr>
         <p:spPr bwMode="auto">
           <a:xfrm>
-            <a:off x="1905000" y="5105400"/>
-            <a:ext cx="7493000" cy="609600"/>
+            <a:off x="1905000" y="3941063"/>
+            <a:ext cx="7493000" cy="493776"/>
           </a:xfrm>
           <a:prstGeom prst="rect">
             <a:avLst/>
@@ -14113,7 +14351,7 @@
                   <a:srgbClr val="073654"/>
                 </a:solidFill>
               </a:rPr>
-              <a:t>Representación y metodología</a:t>
+              <a:t>Metodología de trabajo</a:t>
             </a:r>
             <a:br>
               <a:rPr lang="es-ES" sz="1200">
@@ -14128,7 +14366,7 @@
                   <a:srgbClr val="425466"/>
                 </a:solidFill>
               </a:rPr>
-              <a:t>TF-IDF, embeddings y propuesta de modelado</a:t>
+              <a:t>Fases, reproducibilidad y control de calidad</a:t>
             </a:r>
             <a:endParaRPr lang="es-CO" sz="1200">
               <a:solidFill>
@@ -14146,8 +14384,8 @@
         </p:nvSpPr>
         <p:spPr bwMode="auto">
           <a:xfrm>
-            <a:off x="9906000" y="5156200"/>
-            <a:ext cx="1041400" cy="508000"/>
+            <a:off x="9906000" y="3986783"/>
+            <a:ext cx="1041400" cy="402336"/>
           </a:xfrm>
           <a:prstGeom prst="rect">
             <a:avLst/>
@@ -14169,7 +14407,7 @@
                   <a:srgbClr val="2F75B5"/>
                 </a:solidFill>
               </a:rPr>
-              <a:t>13–14</a:t>
+              <a:t>08</a:t>
             </a:r>
             <a:endParaRPr/>
           </a:p>
@@ -14183,8 +14421,8 @@
         </p:nvSpPr>
         <p:spPr bwMode="auto">
           <a:xfrm>
-            <a:off x="914400" y="5918200"/>
-            <a:ext cx="10363200" cy="812800"/>
+            <a:off x="914400" y="4498848"/>
+            <a:ext cx="10363200" cy="512064"/>
           </a:xfrm>
           <a:prstGeom prst="roundRect">
             <a:avLst>
@@ -14236,8 +14474,8 @@
         </p:nvSpPr>
         <p:spPr bwMode="auto">
           <a:xfrm>
-            <a:off x="1066800" y="6045200"/>
-            <a:ext cx="609600" cy="558800"/>
+            <a:off x="1066800" y="4544568"/>
+            <a:ext cx="609600" cy="420624"/>
           </a:xfrm>
           <a:prstGeom prst="roundRect">
             <a:avLst>
@@ -14297,8 +14535,8 @@
         </p:nvSpPr>
         <p:spPr bwMode="auto">
           <a:xfrm>
-            <a:off x="1905000" y="6019800"/>
-            <a:ext cx="7493000" cy="609600"/>
+            <a:off x="1905000" y="4507992"/>
+            <a:ext cx="7493000" cy="493776"/>
           </a:xfrm>
           <a:prstGeom prst="rect">
             <a:avLst/>
@@ -14320,7 +14558,7 @@
                   <a:srgbClr val="073654"/>
                 </a:solidFill>
               </a:rPr>
-              <a:t>Conclusiones</a:t>
+              <a:t>Corpus medido y EDA avanzado</a:t>
             </a:r>
             <a:br>
               <a:rPr lang="es-ES" sz="1200">
@@ -14335,7 +14573,7 @@
                   <a:srgbClr val="425466"/>
                 </a:solidFill>
               </a:rPr>
-              <a:t>Hallazgos y trabajo futuro</a:t>
+              <a:t>Dataset, n-gramas, diversidad y diacronía</a:t>
             </a:r>
             <a:endParaRPr lang="es-CO" sz="1200">
               <a:solidFill>
@@ -14353,8 +14591,8 @@
         </p:nvSpPr>
         <p:spPr bwMode="auto">
           <a:xfrm>
-            <a:off x="9906000" y="6070600"/>
-            <a:ext cx="1041400" cy="508000"/>
+            <a:off x="9906000" y="4553712"/>
+            <a:ext cx="1041400" cy="402336"/>
           </a:xfrm>
           <a:prstGeom prst="rect">
             <a:avLst/>
@@ -14376,7 +14614,628 @@
                   <a:srgbClr val="6554A4"/>
                 </a:solidFill>
               </a:rPr>
-              <a:t>15</a:t>
+              <a:t>09–14</a:t>
+            </a:r>
+            <a:endParaRPr/>
+          </a:p>
+        </p:txBody>
+      </p:sp>
+      <p:sp>
+        <p:nvSpPr>
+          <p:cNvPr id="2133676726" name="Fusion-G-Fila6-Rectángulo: esquinas redo"/>
+          <p:cNvSpPr/>
+          <p:nvPr/>
+        </p:nvSpPr>
+        <p:spPr bwMode="auto">
+          <a:xfrm>
+            <a:off x="914400" y="5065776"/>
+            <a:ext cx="10363200" cy="512064"/>
+          </a:xfrm>
+          <a:prstGeom prst="roundRect">
+            <a:avLst>
+              <a:gd name="adj" fmla="val 16667"/>
+            </a:avLst>
+          </a:prstGeom>
+          <a:solidFill>
+            <a:srgbClr val="EEEAF8"/>
+          </a:solidFill>
+          <a:ln w="15240" cap="flat" cmpd="sng" algn="ctr">
+            <a:solidFill>
+              <a:srgbClr val="6554A4"/>
+            </a:solidFill>
+            <a:prstDash val="solid"/>
+          </a:ln>
+        </p:spPr>
+        <p:style>
+          <a:lnRef idx="2">
+            <a:schemeClr val="accent1">
+              <a:shade val="15000"/>
+            </a:schemeClr>
+          </a:lnRef>
+          <a:fillRef idx="1">
+            <a:schemeClr val="accent1"/>
+          </a:fillRef>
+          <a:effectRef idx="0">
+            <a:schemeClr val="accent1"/>
+          </a:effectRef>
+          <a:fontRef idx="minor">
+            <a:schemeClr val="lt1"/>
+          </a:fontRef>
+        </p:style>
+        <p:txBody>
+          <a:bodyPr vertOverflow="clip" horzOverflow="clip" rtlCol="0" anchor="t"/>
+          <a:lstStyle/>
+          <a:p>
+            <a:pPr algn="l">
+              <a:defRPr/>
+            </a:pPr>
+            <a:endParaRPr lang="es-CO"/>
+          </a:p>
+        </p:txBody>
+      </p:sp>
+      <p:sp>
+        <p:nvSpPr>
+          <p:cNvPr id="2133676727" name="Fusion-G-Fila6-Rectángulo: esquinas redo"/>
+          <p:cNvSpPr/>
+          <p:nvPr/>
+        </p:nvSpPr>
+        <p:spPr bwMode="auto">
+          <a:xfrm>
+            <a:off x="1066800" y="5111496"/>
+            <a:ext cx="609600" cy="420624"/>
+          </a:xfrm>
+          <a:prstGeom prst="roundRect">
+            <a:avLst>
+              <a:gd name="adj" fmla="val 16667"/>
+            </a:avLst>
+          </a:prstGeom>
+          <a:solidFill>
+            <a:srgbClr val="6554A4"/>
+          </a:solidFill>
+          <a:ln w="25400" cap="flat" cmpd="sng" algn="ctr">
+            <a:noFill/>
+            <a:prstDash val="solid"/>
+          </a:ln>
+        </p:spPr>
+        <p:style>
+          <a:lnRef idx="2">
+            <a:schemeClr val="accent1">
+              <a:shade val="15000"/>
+            </a:schemeClr>
+          </a:lnRef>
+          <a:fillRef idx="1">
+            <a:schemeClr val="accent1"/>
+          </a:fillRef>
+          <a:effectRef idx="0">
+            <a:schemeClr val="accent1"/>
+          </a:effectRef>
+          <a:fontRef idx="minor">
+            <a:schemeClr val="lt1"/>
+          </a:fontRef>
+        </p:style>
+        <p:txBody>
+          <a:bodyPr vertOverflow="clip" horzOverflow="clip" rtlCol="0" anchor="ctr" anchorCtr="0"/>
+          <a:lstStyle/>
+          <a:p>
+            <a:pPr algn="l">
+              <a:defRPr/>
+            </a:pPr>
+            <a:r>
+              <a:rPr lang="es-CO" sz="1700" b="1">
+                <a:solidFill>
+                  <a:srgbClr val="FFFFFF"/>
+                </a:solidFill>
+                <a:latin typeface="Arial"/>
+                <a:cs typeface="Arial"/>
+              </a:rPr>
+              <a:t>06</a:t>
+            </a:r>
+            <a:endParaRPr/>
+          </a:p>
+        </p:txBody>
+      </p:sp>
+      <p:sp>
+        <p:nvSpPr>
+          <p:cNvPr id="2133676728" name="Fusion-G-Fila6-CuadroTexto 19"/>
+          <p:cNvSpPr txBox="1"/>
+          <p:nvPr/>
+        </p:nvSpPr>
+        <p:spPr bwMode="auto">
+          <a:xfrm>
+            <a:off x="1905000" y="5074920"/>
+            <a:ext cx="7493000" cy="493776"/>
+          </a:xfrm>
+          <a:prstGeom prst="rect">
+            <a:avLst/>
+          </a:prstGeom>
+          <a:noFill/>
+        </p:spPr>
+        <p:txBody>
+          <a:bodyPr vertOverflow="overflow" vert="horz" wrap="square" rtlCol="0" anchor="ctr" anchorCtr="0">
+            <a:spAutoFit/>
+          </a:bodyPr>
+          <a:lstStyle/>
+          <a:p>
+            <a:pPr algn="l">
+              <a:defRPr/>
+            </a:pPr>
+            <a:r>
+              <a:rPr lang="es-ES" sz="1800" b="1">
+                <a:solidFill>
+                  <a:srgbClr val="073654"/>
+                </a:solidFill>
+              </a:rPr>
+              <a:t>Representación y metodología</a:t>
+            </a:r>
+            <a:br>
+              <a:rPr lang="es-ES" sz="1200">
+                <a:solidFill>
+                  <a:srgbClr val="425466"/>
+                </a:solidFill>
+              </a:rPr>
+            </a:br>
+            <a:r>
+              <a:rPr lang="es-ES" sz="1200">
+                <a:solidFill>
+                  <a:srgbClr val="425466"/>
+                </a:solidFill>
+              </a:rPr>
+              <a:t>TF-IDF, embeddings y propuesta de modelado</a:t>
+            </a:r>
+            <a:endParaRPr lang="es-CO" sz="1200">
+              <a:solidFill>
+                <a:srgbClr val="425466"/>
+              </a:solidFill>
+            </a:endParaRPr>
+          </a:p>
+        </p:txBody>
+      </p:sp>
+      <p:sp>
+        <p:nvSpPr>
+          <p:cNvPr id="2133676729" name="Fusion-G-Fila6-CuadroTexto 20"/>
+          <p:cNvSpPr txBox="1"/>
+          <p:nvPr/>
+        </p:nvSpPr>
+        <p:spPr bwMode="auto">
+          <a:xfrm>
+            <a:off x="9906000" y="5120640"/>
+            <a:ext cx="1041400" cy="402336"/>
+          </a:xfrm>
+          <a:prstGeom prst="rect">
+            <a:avLst/>
+          </a:prstGeom>
+          <a:noFill/>
+        </p:spPr>
+        <p:txBody>
+          <a:bodyPr vertOverflow="overflow" vert="horz" wrap="square" rtlCol="0" anchor="ctr" anchorCtr="0">
+            <a:spAutoFit/>
+          </a:bodyPr>
+          <a:lstStyle/>
+          <a:p>
+            <a:pPr algn="l">
+              <a:defRPr/>
+            </a:pPr>
+            <a:r>
+              <a:rPr lang="es-CO" sz="1500" b="1">
+                <a:solidFill>
+                  <a:srgbClr val="6554A4"/>
+                </a:solidFill>
+              </a:rPr>
+              <a:t>15–16</a:t>
+            </a:r>
+            <a:endParaRPr/>
+          </a:p>
+        </p:txBody>
+      </p:sp>
+      <p:sp>
+        <p:nvSpPr>
+          <p:cNvPr id="2133676730" name="Fusion-G-Fila7-Rectángulo: esquinas redo"/>
+          <p:cNvSpPr/>
+          <p:nvPr/>
+        </p:nvSpPr>
+        <p:spPr bwMode="auto">
+          <a:xfrm>
+            <a:off x="914400" y="5632704"/>
+            <a:ext cx="10363200" cy="512064"/>
+          </a:xfrm>
+          <a:prstGeom prst="roundRect">
+            <a:avLst>
+              <a:gd name="adj" fmla="val 16667"/>
+            </a:avLst>
+          </a:prstGeom>
+          <a:solidFill>
+            <a:srgbClr val="EEEAF8"/>
+          </a:solidFill>
+          <a:ln w="15240" cap="flat" cmpd="sng" algn="ctr">
+            <a:solidFill>
+              <a:srgbClr val="6554A4"/>
+            </a:solidFill>
+            <a:prstDash val="solid"/>
+          </a:ln>
+        </p:spPr>
+        <p:style>
+          <a:lnRef idx="2">
+            <a:schemeClr val="accent1">
+              <a:shade val="15000"/>
+            </a:schemeClr>
+          </a:lnRef>
+          <a:fillRef idx="1">
+            <a:schemeClr val="accent1"/>
+          </a:fillRef>
+          <a:effectRef idx="0">
+            <a:schemeClr val="accent1"/>
+          </a:effectRef>
+          <a:fontRef idx="minor">
+            <a:schemeClr val="lt1"/>
+          </a:fontRef>
+        </p:style>
+        <p:txBody>
+          <a:bodyPr vertOverflow="clip" horzOverflow="clip" rtlCol="0" anchor="t"/>
+          <a:lstStyle/>
+          <a:p>
+            <a:pPr algn="l">
+              <a:defRPr/>
+            </a:pPr>
+            <a:endParaRPr lang="es-CO"/>
+          </a:p>
+        </p:txBody>
+      </p:sp>
+      <p:sp>
+        <p:nvSpPr>
+          <p:cNvPr id="2133676731" name="Fusion-G-Fila7-Rectángulo: esquinas redo"/>
+          <p:cNvSpPr/>
+          <p:nvPr/>
+        </p:nvSpPr>
+        <p:spPr bwMode="auto">
+          <a:xfrm>
+            <a:off x="1066800" y="5678424"/>
+            <a:ext cx="609600" cy="420624"/>
+          </a:xfrm>
+          <a:prstGeom prst="roundRect">
+            <a:avLst>
+              <a:gd name="adj" fmla="val 16667"/>
+            </a:avLst>
+          </a:prstGeom>
+          <a:solidFill>
+            <a:srgbClr val="6554A4"/>
+          </a:solidFill>
+          <a:ln w="25400" cap="flat" cmpd="sng" algn="ctr">
+            <a:noFill/>
+            <a:prstDash val="solid"/>
+          </a:ln>
+        </p:spPr>
+        <p:style>
+          <a:lnRef idx="2">
+            <a:schemeClr val="accent1">
+              <a:shade val="15000"/>
+            </a:schemeClr>
+          </a:lnRef>
+          <a:fillRef idx="1">
+            <a:schemeClr val="accent1"/>
+          </a:fillRef>
+          <a:effectRef idx="0">
+            <a:schemeClr val="accent1"/>
+          </a:effectRef>
+          <a:fontRef idx="minor">
+            <a:schemeClr val="lt1"/>
+          </a:fontRef>
+        </p:style>
+        <p:txBody>
+          <a:bodyPr vertOverflow="clip" horzOverflow="clip" rtlCol="0" anchor="ctr" anchorCtr="0"/>
+          <a:lstStyle/>
+          <a:p>
+            <a:pPr algn="l">
+              <a:defRPr/>
+            </a:pPr>
+            <a:r>
+              <a:rPr lang="es-CO" sz="1700" b="1">
+                <a:solidFill>
+                  <a:srgbClr val="FFFFFF"/>
+                </a:solidFill>
+                <a:latin typeface="Arial"/>
+                <a:cs typeface="Arial"/>
+              </a:rPr>
+              <a:t>07</a:t>
+            </a:r>
+            <a:endParaRPr/>
+          </a:p>
+        </p:txBody>
+      </p:sp>
+      <p:sp>
+        <p:nvSpPr>
+          <p:cNvPr id="2133676732" name="Fusion-G-Fila7-CuadroTexto 19"/>
+          <p:cNvSpPr txBox="1"/>
+          <p:nvPr/>
+        </p:nvSpPr>
+        <p:spPr bwMode="auto">
+          <a:xfrm>
+            <a:off x="1905000" y="5641848"/>
+            <a:ext cx="7493000" cy="493776"/>
+          </a:xfrm>
+          <a:prstGeom prst="rect">
+            <a:avLst/>
+          </a:prstGeom>
+          <a:noFill/>
+        </p:spPr>
+        <p:txBody>
+          <a:bodyPr vertOverflow="overflow" vert="horz" wrap="square" rtlCol="0" anchor="ctr" anchorCtr="0">
+            <a:spAutoFit/>
+          </a:bodyPr>
+          <a:lstStyle/>
+          <a:p>
+            <a:pPr algn="l">
+              <a:defRPr/>
+            </a:pPr>
+            <a:r>
+              <a:rPr lang="es-ES" sz="1800" b="1">
+                <a:solidFill>
+                  <a:srgbClr val="073654"/>
+                </a:solidFill>
+              </a:rPr>
+              <a:t>Trabajos futuros</a:t>
+            </a:r>
+            <a:br>
+              <a:rPr lang="es-ES" sz="1200">
+                <a:solidFill>
+                  <a:srgbClr val="425466"/>
+                </a:solidFill>
+              </a:rPr>
+            </a:br>
+            <a:r>
+              <a:rPr lang="es-ES" sz="1200">
+                <a:solidFill>
+                  <a:srgbClr val="425466"/>
+                </a:solidFill>
+              </a:rPr>
+              <a:t>Validación, modelado y aplicaciones</a:t>
+            </a:r>
+            <a:endParaRPr lang="es-CO" sz="1200">
+              <a:solidFill>
+                <a:srgbClr val="425466"/>
+              </a:solidFill>
+            </a:endParaRPr>
+          </a:p>
+        </p:txBody>
+      </p:sp>
+      <p:sp>
+        <p:nvSpPr>
+          <p:cNvPr id="2133676733" name="Fusion-G-Fila7-CuadroTexto 20"/>
+          <p:cNvSpPr txBox="1"/>
+          <p:nvPr/>
+        </p:nvSpPr>
+        <p:spPr bwMode="auto">
+          <a:xfrm>
+            <a:off x="9906000" y="5687568"/>
+            <a:ext cx="1041400" cy="402336"/>
+          </a:xfrm>
+          <a:prstGeom prst="rect">
+            <a:avLst/>
+          </a:prstGeom>
+          <a:noFill/>
+        </p:spPr>
+        <p:txBody>
+          <a:bodyPr vertOverflow="overflow" vert="horz" wrap="square" rtlCol="0" anchor="ctr" anchorCtr="0">
+            <a:spAutoFit/>
+          </a:bodyPr>
+          <a:lstStyle/>
+          <a:p>
+            <a:pPr algn="l">
+              <a:defRPr/>
+            </a:pPr>
+            <a:r>
+              <a:rPr lang="es-CO" sz="1500" b="1">
+                <a:solidFill>
+                  <a:srgbClr val="6554A4"/>
+                </a:solidFill>
+              </a:rPr>
+              <a:t>17</a:t>
+            </a:r>
+            <a:endParaRPr/>
+          </a:p>
+        </p:txBody>
+      </p:sp>
+      <p:sp>
+        <p:nvSpPr>
+          <p:cNvPr id="2133676734" name="Fusion-G-Fila8-Rectángulo: esquinas redo"/>
+          <p:cNvSpPr/>
+          <p:nvPr/>
+        </p:nvSpPr>
+        <p:spPr bwMode="auto">
+          <a:xfrm>
+            <a:off x="914400" y="6199631"/>
+            <a:ext cx="10363200" cy="512064"/>
+          </a:xfrm>
+          <a:prstGeom prst="roundRect">
+            <a:avLst>
+              <a:gd name="adj" fmla="val 16667"/>
+            </a:avLst>
+          </a:prstGeom>
+          <a:solidFill>
+            <a:srgbClr val="EEEAF8"/>
+          </a:solidFill>
+          <a:ln w="15240" cap="flat" cmpd="sng" algn="ctr">
+            <a:solidFill>
+              <a:srgbClr val="6554A4"/>
+            </a:solidFill>
+            <a:prstDash val="solid"/>
+          </a:ln>
+        </p:spPr>
+        <p:style>
+          <a:lnRef idx="2">
+            <a:schemeClr val="accent1">
+              <a:shade val="15000"/>
+            </a:schemeClr>
+          </a:lnRef>
+          <a:fillRef idx="1">
+            <a:schemeClr val="accent1"/>
+          </a:fillRef>
+          <a:effectRef idx="0">
+            <a:schemeClr val="accent1"/>
+          </a:effectRef>
+          <a:fontRef idx="minor">
+            <a:schemeClr val="lt1"/>
+          </a:fontRef>
+        </p:style>
+        <p:txBody>
+          <a:bodyPr vertOverflow="clip" horzOverflow="clip" rtlCol="0" anchor="t"/>
+          <a:lstStyle/>
+          <a:p>
+            <a:pPr algn="l">
+              <a:defRPr/>
+            </a:pPr>
+            <a:endParaRPr lang="es-CO"/>
+          </a:p>
+        </p:txBody>
+      </p:sp>
+      <p:sp>
+        <p:nvSpPr>
+          <p:cNvPr id="2133676735" name="Fusion-G-Fila8-Rectángulo: esquinas redo"/>
+          <p:cNvSpPr/>
+          <p:nvPr/>
+        </p:nvSpPr>
+        <p:spPr bwMode="auto">
+          <a:xfrm>
+            <a:off x="1066800" y="6245351"/>
+            <a:ext cx="609600" cy="420624"/>
+          </a:xfrm>
+          <a:prstGeom prst="roundRect">
+            <a:avLst>
+              <a:gd name="adj" fmla="val 16667"/>
+            </a:avLst>
+          </a:prstGeom>
+          <a:solidFill>
+            <a:srgbClr val="6554A4"/>
+          </a:solidFill>
+          <a:ln w="25400" cap="flat" cmpd="sng" algn="ctr">
+            <a:noFill/>
+            <a:prstDash val="solid"/>
+          </a:ln>
+        </p:spPr>
+        <p:style>
+          <a:lnRef idx="2">
+            <a:schemeClr val="accent1">
+              <a:shade val="15000"/>
+            </a:schemeClr>
+          </a:lnRef>
+          <a:fillRef idx="1">
+            <a:schemeClr val="accent1"/>
+          </a:fillRef>
+          <a:effectRef idx="0">
+            <a:schemeClr val="accent1"/>
+          </a:effectRef>
+          <a:fontRef idx="minor">
+            <a:schemeClr val="lt1"/>
+          </a:fontRef>
+        </p:style>
+        <p:txBody>
+          <a:bodyPr vertOverflow="clip" horzOverflow="clip" rtlCol="0" anchor="ctr" anchorCtr="0"/>
+          <a:lstStyle/>
+          <a:p>
+            <a:pPr algn="l">
+              <a:defRPr/>
+            </a:pPr>
+            <a:r>
+              <a:rPr lang="es-CO" sz="1700" b="1">
+                <a:solidFill>
+                  <a:srgbClr val="FFFFFF"/>
+                </a:solidFill>
+                <a:latin typeface="Arial"/>
+                <a:cs typeface="Arial"/>
+              </a:rPr>
+              <a:t>08</a:t>
+            </a:r>
+            <a:endParaRPr/>
+          </a:p>
+        </p:txBody>
+      </p:sp>
+      <p:sp>
+        <p:nvSpPr>
+          <p:cNvPr id="2133676736" name="Fusion-G-Fila8-CuadroTexto 19"/>
+          <p:cNvSpPr txBox="1"/>
+          <p:nvPr/>
+        </p:nvSpPr>
+        <p:spPr bwMode="auto">
+          <a:xfrm>
+            <a:off x="1905000" y="6208775"/>
+            <a:ext cx="7493000" cy="493776"/>
+          </a:xfrm>
+          <a:prstGeom prst="rect">
+            <a:avLst/>
+          </a:prstGeom>
+          <a:noFill/>
+        </p:spPr>
+        <p:txBody>
+          <a:bodyPr vertOverflow="overflow" vert="horz" wrap="square" rtlCol="0" anchor="ctr" anchorCtr="0">
+            <a:spAutoFit/>
+          </a:bodyPr>
+          <a:lstStyle/>
+          <a:p>
+            <a:pPr algn="l">
+              <a:defRPr/>
+            </a:pPr>
+            <a:r>
+              <a:rPr lang="es-ES" sz="1800" b="1">
+                <a:solidFill>
+                  <a:srgbClr val="073654"/>
+                </a:solidFill>
+              </a:rPr>
+              <a:t>Conclusiones</a:t>
+            </a:r>
+            <a:br>
+              <a:rPr lang="es-ES" sz="1200">
+                <a:solidFill>
+                  <a:srgbClr val="425466"/>
+                </a:solidFill>
+              </a:rPr>
+            </a:br>
+            <a:r>
+              <a:rPr lang="es-ES" sz="1200">
+                <a:solidFill>
+                  <a:srgbClr val="425466"/>
+                </a:solidFill>
+              </a:rPr>
+              <a:t>Hallazgos principales</a:t>
+            </a:r>
+            <a:endParaRPr lang="es-CO" sz="1200">
+              <a:solidFill>
+                <a:srgbClr val="425466"/>
+              </a:solidFill>
+            </a:endParaRPr>
+          </a:p>
+        </p:txBody>
+      </p:sp>
+      <p:sp>
+        <p:nvSpPr>
+          <p:cNvPr id="2133676737" name="Fusion-G-Fila8-CuadroTexto 20"/>
+          <p:cNvSpPr txBox="1"/>
+          <p:nvPr/>
+        </p:nvSpPr>
+        <p:spPr bwMode="auto">
+          <a:xfrm>
+            <a:off x="9906000" y="6254495"/>
+            <a:ext cx="1041400" cy="402336"/>
+          </a:xfrm>
+          <a:prstGeom prst="rect">
+            <a:avLst/>
+          </a:prstGeom>
+          <a:noFill/>
+        </p:spPr>
+        <p:txBody>
+          <a:bodyPr vertOverflow="overflow" vert="horz" wrap="square" rtlCol="0" anchor="ctr" anchorCtr="0">
+            <a:spAutoFit/>
+          </a:bodyPr>
+          <a:lstStyle/>
+          <a:p>
+            <a:pPr algn="l">
+              <a:defRPr/>
+            </a:pPr>
+            <a:r>
+              <a:rPr lang="es-CO" sz="1500" b="1">
+                <a:solidFill>
+                  <a:srgbClr val="6554A4"/>
+                </a:solidFill>
+              </a:rPr>
+              <a:t>18</a:t>
             </a:r>
             <a:endParaRPr/>
           </a:p>
@@ -17171,7 +18030,7 @@
             </a:r>
             <a:r>
               <a:rPr lang="es-ES" dirty="0" sz="1800"/>
-              <a:t>parquet de 23.742 filas × 12 columnas con texto, texto limpio y métricas por documento.</a:t>
+              <a:t>23.742 filas × 12 columnas con texto, texto limpio y métricas por documento.</a:t>
             </a:r>
           </a:p>
           <a:p>
@@ -17692,7 +18551,7 @@
                 <a:latin typeface="Arial"/>
                 <a:cs typeface="Arial"/>
               </a:rPr>
-              <a:t>TAMAÑO DEL PARQUET</a:t>
+              <a:t>TAMAÑO DEL CONJUNTO</a:t>
             </a:r>
             <a:endParaRPr/>
           </a:p>
@@ -18352,7 +19211,7 @@
                 </a:solidFill>
                 <a:ea typeface="Calibri"/>
               </a:rPr>
-              <a:t>N-gramas y colocaciones</a:t>
+              <a:t>N-gramas y espectro de frecuencias</a:t>
             </a:r>
             <a:endParaRPr/>
           </a:p>
@@ -18404,8 +19263,8 @@
         </p:blipFill>
         <p:spPr>
           <a:xfrm>
-            <a:off x="722376" y="2693810"/>
-            <a:ext cx="5038344" cy="2156178"/>
+            <a:off x="502920" y="2715457"/>
+            <a:ext cx="5532120" cy="2250044"/>
           </a:xfrm>
           <a:prstGeom prst="rect">
             <a:avLst/>
@@ -18414,7 +19273,7 @@
       </p:pic>
       <p:pic>
         <p:nvPicPr>
-          <p:cNvPr id="2133676187" name="E2-Fig-Colocaciones" descr="fig_colocaciones.png"/>
+          <p:cNvPr id="2133676187" name="E2-Fig-Espectro" descr="fig_espectro_frecuencias.png"/>
           <p:cNvPicPr>
             <a:picLocks noChangeAspect="1"/>
           </p:cNvPicPr>
@@ -18428,8 +19287,8 @@
         </p:blipFill>
         <p:spPr>
           <a:xfrm>
-            <a:off x="6483096" y="2694328"/>
-            <a:ext cx="5038344" cy="2155143"/>
+            <a:off x="6153912" y="2713636"/>
+            <a:ext cx="5532120" cy="2253686"/>
           </a:xfrm>
           <a:prstGeom prst="rect">
             <a:avLst/>
@@ -18444,8 +19303,8 @@
         </p:nvSpPr>
         <p:spPr>
           <a:xfrm>
-            <a:off x="722376" y="4956048"/>
-            <a:ext cx="5038344" cy="292608"/>
+            <a:off x="502920" y="5074920"/>
+            <a:ext cx="5532120" cy="292608"/>
           </a:xfrm>
           <a:prstGeom prst="rect">
             <a:avLst/>
@@ -18479,8 +19338,8 @@
         </p:nvSpPr>
         <p:spPr>
           <a:xfrm>
-            <a:off x="6483096" y="4956048"/>
-            <a:ext cx="5038344" cy="292608"/>
+            <a:off x="6153912" y="5074920"/>
+            <a:ext cx="5532120" cy="292608"/>
           </a:xfrm>
           <a:prstGeom prst="rect">
             <a:avLst/>
@@ -18501,7 +19360,7 @@
                 </a:solidFill>
                 <a:latin typeface="Arial"/>
               </a:rPr>
-              <a:t>Colocaciones por LLR (top-10): LLR 75 % vs frecuencia 55 % y PMI 0 %.</a:t>
+              <a:t>Espectro de frecuencias: 33,0 % de hápax; el 4,4 % de los tipos concentra el 93,5 % de los tokens.</a:t>
             </a:r>
           </a:p>
         </p:txBody>
@@ -18768,8 +19627,8 @@
         </p:blipFill>
         <p:spPr>
           <a:xfrm>
-            <a:off x="722376" y="2877376"/>
-            <a:ext cx="5038344" cy="1789047"/>
+            <a:off x="502920" y="2803969"/>
+            <a:ext cx="5532120" cy="2073020"/>
           </a:xfrm>
           <a:prstGeom prst="rect">
             <a:avLst/>
@@ -18792,8 +19651,8 @@
         </p:blipFill>
         <p:spPr>
           <a:xfrm>
-            <a:off x="6483096" y="2725539"/>
-            <a:ext cx="5038344" cy="2092720"/>
+            <a:off x="6153912" y="2673897"/>
+            <a:ext cx="5532120" cy="2333164"/>
           </a:xfrm>
           <a:prstGeom prst="rect">
             <a:avLst/>
@@ -18808,8 +19667,8 @@
         </p:nvSpPr>
         <p:spPr>
           <a:xfrm>
-            <a:off x="722376" y="4956048"/>
-            <a:ext cx="5038344" cy="292608"/>
+            <a:off x="502920" y="5074920"/>
+            <a:ext cx="5532120" cy="292608"/>
           </a:xfrm>
           <a:prstGeom prst="rect">
             <a:avLst/>
@@ -18843,8 +19702,8 @@
         </p:nvSpPr>
         <p:spPr>
           <a:xfrm>
-            <a:off x="6483096" y="4956048"/>
-            <a:ext cx="5038344" cy="292608"/>
+            <a:off x="6153912" y="5074920"/>
+            <a:ext cx="5532120" cy="292608"/>
           </a:xfrm>
           <a:prstGeom prst="rect">
             <a:avLst/>
@@ -19132,8 +19991,8 @@
         </p:blipFill>
         <p:spPr>
           <a:xfrm>
-            <a:off x="2227399" y="2331720"/>
-            <a:ext cx="7734153" cy="3291840"/>
+            <a:off x="2439451" y="2331720"/>
+            <a:ext cx="7310048" cy="3291840"/>
           </a:xfrm>
           <a:prstGeom prst="rect">
             <a:avLst/>
@@ -19657,7 +20516,7 @@
                 </a:solidFill>
                 <a:ea typeface="Calibri"/>
               </a:rPr>
-              <a:t>TF-IDF sobre lemas y embeddings</a:t>
+              <a:t>TF-IDF sobre lemas y ventana de 512 tokens</a:t>
             </a:r>
             <a:endParaRPr/>
           </a:p>
@@ -19709,8 +20568,8 @@
         </p:blipFill>
         <p:spPr>
           <a:xfrm>
-            <a:off x="722376" y="2796788"/>
-            <a:ext cx="5038344" cy="1995942"/>
+            <a:off x="502920" y="2750154"/>
+            <a:ext cx="5532120" cy="2180650"/>
           </a:xfrm>
           <a:prstGeom prst="rect">
             <a:avLst/>
@@ -19719,7 +20578,7 @@
       </p:pic>
       <p:pic>
         <p:nvPicPr>
-          <p:cNvPr id="2133676427" name="E2-Fig-Embeddings" descr="fig_embeddings_ejemplo.png"/>
+          <p:cNvPr id="2133676427" name="E2-Fig-Ventana" descr="fig_longitud_vs_ventana.png"/>
           <p:cNvPicPr>
             <a:picLocks noChangeAspect="1"/>
           </p:cNvPicPr>
@@ -19733,8 +20592,8 @@
         </p:blipFill>
         <p:spPr>
           <a:xfrm>
-            <a:off x="7736090" y="2651760"/>
-            <a:ext cx="2532355" cy="2286000"/>
+            <a:off x="6153912" y="2775277"/>
+            <a:ext cx="5532120" cy="2130405"/>
           </a:xfrm>
           <a:prstGeom prst="rect">
             <a:avLst/>
@@ -19749,8 +20608,8 @@
         </p:nvSpPr>
         <p:spPr>
           <a:xfrm>
-            <a:off x="722376" y="5029200"/>
-            <a:ext cx="5038344" cy="292608"/>
+            <a:off x="502920" y="5074920"/>
+            <a:ext cx="5532120" cy="292608"/>
           </a:xfrm>
           <a:prstGeom prst="rect">
             <a:avLst/>
@@ -19784,8 +20643,8 @@
         </p:nvSpPr>
         <p:spPr>
           <a:xfrm>
-            <a:off x="6483096" y="5029200"/>
-            <a:ext cx="5038344" cy="292608"/>
+            <a:off x="6153912" y="5074920"/>
+            <a:ext cx="5532120" cy="292608"/>
           </a:xfrm>
           <a:prstGeom prst="rect">
             <a:avLst/>
@@ -19806,7 +20665,7 @@
                 </a:solidFill>
                 <a:latin typeface="Arial"/>
               </a:rPr>
-              <a:t>e5-base: similitud coseno entre cinco documentos (768 dimensiones).</a:t>
+              <a:t>Ventana de 512 tokens: 99,95 % de los documentos la excede (T 99,94 · C 99,95 · SU 100).</a:t>
             </a:r>
           </a:p>
         </p:txBody>
@@ -19878,7 +20737,7 @@
                 <a:latin typeface="Arial"/>
                 <a:cs typeface="Arial"/>
               </a:rPr>
-              <a:t>  |  TF-IDF sobre lemas: 23.742 × 100.000, 95,66 % de esparsidad, ajuste en ≈ 212 s; embeddings e5: similitud media 0,899 (0,91-0,92 entre los documentos representativos).</a:t>
+              <a:t>  |  TF-IDF sobre lemas: 23.742 × 100.000, 95,66 % de esparsidad (ajuste en ≈ 200 s); el 99,95 % de los documentos excede la ventana de 512 tokens de los modelos contextuales.</a:t>
             </a:r>
             <a:endParaRPr lang="es-CO" sz="1300">
               <a:solidFill>
@@ -20892,6 +21751,967 @@
               <a:latin typeface="Arial"/>
               <a:cs typeface="Arial"/>
             </a:endParaRPr>
+          </a:p>
+        </p:txBody>
+      </p:sp>
+    </p:spTree>
+  </p:cSld>
+  <p:clrMapOvr>
+    <a:masterClrMapping/>
+  </p:clrMapOvr>
+</p:sld>
+</file>
+
+<file path=ppt/slides/slide36.xml><?xml version="1.0" encoding="utf-8"?>
+<p:sld xmlns:a="http://schemas.openxmlformats.org/drawingml/2006/main" xmlns:p="http://schemas.openxmlformats.org/presentationml/2006/main" xmlns:r="http://schemas.openxmlformats.org/officeDocument/2006/relationships">
+  <p:cSld>
+    <p:spTree>
+      <p:nvGrpSpPr>
+        <p:cNvPr id="2133676599" name=""/>
+        <p:cNvGrpSpPr/>
+        <p:nvPr/>
+      </p:nvGrpSpPr>
+      <p:grpSpPr/>
+      <p:pic>
+        <p:nvPicPr>
+          <p:cNvPr id="2133676600" name="Google Shape;104;g393f66bba02_1_6"/>
+          <p:cNvPicPr/>
+          <p:nvPr/>
+        </p:nvPicPr>
+        <p:blipFill rotWithShape="1">
+          <a:blip r:embed="rId2">
+            <a:alphaModFix/>
+          </a:blip>
+          <a:stretch/>
+        </p:blipFill>
+        <p:spPr bwMode="auto">
+          <a:xfrm>
+            <a:off x="-1" y="0"/>
+            <a:ext cx="12192004" cy="1623060"/>
+          </a:xfrm>
+          <a:prstGeom prst="rect">
+            <a:avLst/>
+          </a:prstGeom>
+          <a:noFill/>
+          <a:ln>
+            <a:noFill/>
+          </a:ln>
+        </p:spPr>
+      </p:pic>
+      <p:sp>
+        <p:nvSpPr>
+          <p:cNvPr id="2133676601" name="Google Shape;105;g393f66bba02_1_6"/>
+          <p:cNvSpPr/>
+          <p:nvPr/>
+        </p:nvSpPr>
+        <p:spPr bwMode="auto">
+          <a:xfrm>
+            <a:off x="1496965" y="324857"/>
+            <a:ext cx="6824075" cy="923400"/>
+          </a:xfrm>
+          <a:prstGeom prst="rect">
+            <a:avLst/>
+          </a:prstGeom>
+          <a:noFill/>
+          <a:ln>
+            <a:noFill/>
+          </a:ln>
+        </p:spPr>
+        <p:txBody>
+          <a:bodyPr spcFirstLastPara="1" wrap="square" lIns="91425" tIns="45700" rIns="91425" bIns="45700" anchor="t" anchorCtr="0">
+            <a:noAutofit/>
+            <a:noAutofit/>
+          </a:bodyPr>
+          <a:lstStyle/>
+          <a:p>
+            <a:pPr lvl="0">
+              <a:defRPr/>
+            </a:pPr>
+            <a:r>
+              <a:rPr lang="es-CO" sz="3200" b="1">
+                <a:solidFill>
+                  <a:schemeClr val="bg1"/>
+                </a:solidFill>
+                <a:latin typeface="Calibri"/>
+                <a:ea typeface="Calibri"/>
+                <a:cs typeface="Calibri"/>
+              </a:rPr>
+              <a:t>Metodología de trabajo</a:t>
+            </a:r>
+            <a:endParaRPr lang="es-CO" sz="3200" b="1" i="0" u="none" strike="noStrike" cap="none">
+              <a:solidFill>
+                <a:schemeClr val="bg1"/>
+              </a:solidFill>
+              <a:latin typeface="Calibri"/>
+              <a:ea typeface="Calibri"/>
+              <a:cs typeface="Calibri"/>
+            </a:endParaRPr>
+          </a:p>
+        </p:txBody>
+      </p:sp>
+      <p:sp>
+        <p:nvSpPr>
+          <p:cNvPr id="2133676602" name="E2-Met-Cuerpo"/>
+          <p:cNvSpPr txBox="1"/>
+          <p:nvPr/>
+        </p:nvSpPr>
+        <p:spPr bwMode="auto">
+          <a:xfrm>
+            <a:off x="685800" y="2463393"/>
+            <a:ext cx="10442448" cy="3297326"/>
+          </a:xfrm>
+          <a:prstGeom prst="rect">
+            <a:avLst/>
+          </a:prstGeom>
+          <a:noFill/>
+        </p:spPr>
+        <p:txBody>
+          <a:bodyPr rot="0" spcFirstLastPara="0" vertOverflow="overflow" horzOverflow="overflow" vert="horz" wrap="square" lIns="91440" tIns="45720" rIns="91440" bIns="45720" numCol="1" spcCol="0" rtlCol="0" fromWordArt="0" anchor="t" anchorCtr="0" forceAA="0" compatLnSpc="1">
+            <a:prstTxWarp prst="textNoShape"/>
+            <a:spAutoFit/>
+          </a:bodyPr>
+          <a:lstStyle/>
+          <a:p>
+            <a:pPr lvl="1" marL="742950" indent="-285750">
+              <a:buFont typeface="Courier New"/>
+              <a:buChar char="o"/>
+            </a:pPr>
+            <a:r>
+              <a:rPr lang="es-ES" dirty="0" sz="1800" b="1"/>
+              <a:t>Proceso por fases con puertas de calidad: </a:t>
+            </a:r>
+            <a:r>
+              <a:rPr lang="es-ES" dirty="0" sz="1800"/>
+              <a:t>comprensión de datos → preparación → análisis → representación; el modelado es la siguiente fase.</a:t>
+            </a:r>
+          </a:p>
+          <a:p>
+            <a:pPr lvl="1" marL="742950" indent="-285750">
+              <a:buFont typeface="Courier New"/>
+              <a:buChar char="o"/>
+            </a:pPr>
+            <a:r>
+              <a:rPr lang="es-ES" dirty="0" sz="1800" b="1"/>
+              <a:t>Reproducibilidad y trazabilidad: </a:t>
+            </a:r>
+            <a:r>
+              <a:rPr lang="es-ES" dirty="0" sz="1800"/>
+              <a:t>limpieza documentada por etapas; semilla fija (42); análisis ejecutado de punta a punta y sellado (huella digital); cada cifra trazable a su fuente.</a:t>
+            </a:r>
+          </a:p>
+          <a:p>
+            <a:pPr lvl="1" marL="742950" indent="-285750">
+              <a:buFont typeface="Courier New"/>
+              <a:buChar char="o"/>
+            </a:pPr>
+            <a:r>
+              <a:rPr lang="es-ES" dirty="0" sz="1800" b="1"/>
+              <a:t>Decisiones con evidencia: </a:t>
+            </a:r>
+            <a:r>
+              <a:rPr lang="es-ES" dirty="0" sz="1800"/>
+              <a:t>criterios pre-registrados (p. ej., granularidad), validación manual de colocaciones y alternativas evaluadas y registradas.</a:t>
+            </a:r>
+          </a:p>
+          <a:p>
+            <a:pPr lvl="1" marL="742950" indent="-285750">
+              <a:buFont typeface="Courier New"/>
+              <a:buChar char="o"/>
+            </a:pPr>
+            <a:r>
+              <a:rPr lang="es-ES" dirty="0" sz="1800" b="1"/>
+              <a:t>Control de calidad: </a:t>
+            </a:r>
+            <a:r>
+              <a:rPr lang="es-ES" dirty="0" sz="1800"/>
+              <a:t>revisión de código independiente y auditorías que recomputan las cifras desde los datos.</a:t>
+            </a:r>
+          </a:p>
+          <a:p>
+            <a:pPr lvl="1" marL="742950" indent="-285750">
+              <a:buFont typeface="Courier New"/>
+              <a:buChar char="o"/>
+            </a:pPr>
+            <a:r>
+              <a:rPr lang="es-ES" dirty="0" sz="1800" b="1"/>
+              <a:t>Herramientas: </a:t>
+            </a:r>
+            <a:r>
+              <a:rPr lang="es-ES" dirty="0" sz="1800"/>
+              <a:t>Python (pandas, NumPy, spaCy, scikit-learn, pyarrow, NLTK, matplotlib), Jupyter y LaTeX.</a:t>
+            </a:r>
+          </a:p>
+        </p:txBody>
+      </p:sp>
+      <p:sp>
+        <p:nvSpPr>
+          <p:cNvPr id="2133676603" name="TextBox 7"/>
+          <p:cNvSpPr txBox="1"/>
+          <p:nvPr/>
+        </p:nvSpPr>
+        <p:spPr bwMode="auto">
+          <a:xfrm>
+            <a:off x="2127647" y="1609925"/>
+            <a:ext cx="8896906" cy="523220"/>
+          </a:xfrm>
+          <a:prstGeom prst="rect">
+            <a:avLst/>
+          </a:prstGeom>
+          <a:noFill/>
+        </p:spPr>
+        <p:txBody>
+          <a:bodyPr rot="0" spcFirstLastPara="0" vertOverflow="overflow" horzOverflow="overflow" vert="horz" wrap="square" lIns="91440" tIns="45720" rIns="91440" bIns="45720" numCol="1" spcCol="0" rtlCol="0" fromWordArt="0" anchor="t" anchorCtr="0" forceAA="0" compatLnSpc="1">
+            <a:prstTxWarp prst="textNoShape"/>
+            <a:spAutoFit/>
+          </a:bodyPr>
+          <a:lstStyle/>
+          <a:p>
+            <a:pPr>
+              <a:defRPr/>
+            </a:pPr>
+            <a:r>
+              <a:rPr lang="es-CO" sz="2800" b="1">
+                <a:solidFill>
+                  <a:schemeClr val="accent4">
+                    <a:lumMod val="60000"/>
+                    <a:lumOff val="40000"/>
+                  </a:schemeClr>
+                </a:solidFill>
+                <a:ea typeface="Calibri"/>
+              </a:rPr>
+              <a:t>Fases, reproducibilidad y control de calidad</a:t>
+            </a:r>
+            <a:endParaRPr/>
+          </a:p>
+        </p:txBody>
+      </p:sp>
+      <p:pic>
+        <p:nvPicPr>
+          <p:cNvPr id="2133676604" name="Imagen 2"/>
+          <p:cNvPicPr>
+            <a:picLocks noChangeAspect="1"/>
+          </p:cNvPicPr>
+          <p:nvPr/>
+        </p:nvPicPr>
+        <p:blipFill rotWithShape="1">
+          <a:blip r:embed="rId3">
+            <a:duotone>
+              <a:schemeClr val="accent5">
+                <a:shade val="45000"/>
+                <a:satMod val="135000"/>
+              </a:schemeClr>
+              <a:prstClr val="white"/>
+            </a:duotone>
+          </a:blip>
+          <a:stretch/>
+        </p:blipFill>
+        <p:spPr bwMode="auto">
+          <a:xfrm>
+            <a:off x="1227647" y="1426521"/>
+            <a:ext cx="900000" cy="900000"/>
+          </a:xfrm>
+          <a:prstGeom prst="rect">
+            <a:avLst/>
+          </a:prstGeom>
+        </p:spPr>
+      </p:pic>
+      <p:sp>
+        <p:nvSpPr>
+          <p:cNvPr id="1231742581" name="E2-Flujo"/>
+          <p:cNvSpPr/>
+          <p:nvPr/>
+        </p:nvSpPr>
+        <p:spPr bwMode="auto">
+          <a:xfrm>
+            <a:off x="786384" y="5897880"/>
+            <a:ext cx="10579608" cy="786384"/>
+          </a:xfrm>
+          <a:prstGeom prst="roundRect">
+            <a:avLst>
+              <a:gd name="adj" fmla="val 16667"/>
+            </a:avLst>
+          </a:prstGeom>
+          <a:solidFill>
+            <a:srgbClr val="073654"/>
+          </a:solidFill>
+          <a:ln w="25400" cap="flat" cmpd="sng" algn="ctr">
+            <a:noFill/>
+            <a:prstDash val="solid"/>
+          </a:ln>
+        </p:spPr>
+        <p:style>
+          <a:lnRef idx="2">
+            <a:schemeClr val="accent1">
+              <a:shade val="15000"/>
+            </a:schemeClr>
+          </a:lnRef>
+          <a:fillRef idx="1">
+            <a:schemeClr val="accent1"/>
+          </a:fillRef>
+          <a:effectRef idx="0">
+            <a:schemeClr val="accent1"/>
+          </a:effectRef>
+          <a:fontRef idx="minor">
+            <a:schemeClr val="lt1"/>
+          </a:fontRef>
+        </p:style>
+        <p:txBody>
+          <a:bodyPr vertOverflow="clip" horzOverflow="clip" rtlCol="0" anchor="ctr" anchorCtr="0">
+            <a:normAutofit/>
+          </a:bodyPr>
+          <a:lstStyle/>
+          <a:p>
+            <a:pPr algn="l">
+              <a:defRPr/>
+            </a:pPr>
+            <a:r>
+              <a:rPr lang="es-ES" sz="1800" b="1">
+                <a:solidFill>
+                  <a:srgbClr val="FFFFFF"/>
+                </a:solidFill>
+                <a:latin typeface="Arial"/>
+                <a:cs typeface="Arial"/>
+              </a:rPr>
+              <a:t>FLUJO  →  Corpus (23.742 sentencias)  →  Limpieza  →  Dataset medido</a:t>
+            </a:r>
+            <a:br>
+              <a:rPr lang="es-ES" sz="1800" b="1">
+                <a:solidFill>
+                  <a:srgbClr val="FFFFFF"/>
+                </a:solidFill>
+                <a:latin typeface="Arial"/>
+                <a:cs typeface="Arial"/>
+              </a:rPr>
+            </a:br>
+            <a:r>
+              <a:rPr lang="es-ES" sz="1800" b="1">
+                <a:solidFill>
+                  <a:srgbClr val="FFFFFF"/>
+                </a:solidFill>
+                <a:latin typeface="Arial"/>
+                <a:cs typeface="Arial"/>
+              </a:rPr>
+              <a:t>→  EDA avanzado  →  Representación  →  Modelado (siguiente fase)</a:t>
+            </a:r>
+            <a:endParaRPr lang="es-CO" sz="1800" b="1">
+              <a:solidFill>
+                <a:srgbClr val="FFFFFF"/>
+              </a:solidFill>
+              <a:latin typeface="Arial"/>
+              <a:cs typeface="Arial"/>
+            </a:endParaRPr>
+          </a:p>
+        </p:txBody>
+      </p:sp>
+    </p:spTree>
+  </p:cSld>
+  <p:clrMapOvr>
+    <a:masterClrMapping/>
+  </p:clrMapOvr>
+</p:sld>
+</file>
+
+<file path=ppt/slides/slide37.xml><?xml version="1.0" encoding="utf-8"?>
+<p:sld xmlns:a="http://schemas.openxmlformats.org/drawingml/2006/main" xmlns:p="http://schemas.openxmlformats.org/presentationml/2006/main" xmlns:r="http://schemas.openxmlformats.org/officeDocument/2006/relationships">
+  <p:cSld>
+    <p:spTree>
+      <p:nvGrpSpPr>
+        <p:cNvPr id="2133676659" name=""/>
+        <p:cNvGrpSpPr/>
+        <p:nvPr/>
+      </p:nvGrpSpPr>
+      <p:grpSpPr/>
+      <p:pic>
+        <p:nvPicPr>
+          <p:cNvPr id="2133676660" name="Google Shape;104;g393f66bba02_1_6"/>
+          <p:cNvPicPr/>
+          <p:nvPr/>
+        </p:nvPicPr>
+        <p:blipFill rotWithShape="1">
+          <a:blip r:embed="rId2">
+            <a:alphaModFix/>
+          </a:blip>
+          <a:stretch/>
+        </p:blipFill>
+        <p:spPr bwMode="auto">
+          <a:xfrm>
+            <a:off x="-1" y="0"/>
+            <a:ext cx="12192004" cy="1623060"/>
+          </a:xfrm>
+          <a:prstGeom prst="rect">
+            <a:avLst/>
+          </a:prstGeom>
+          <a:noFill/>
+          <a:ln>
+            <a:noFill/>
+          </a:ln>
+        </p:spPr>
+      </p:pic>
+      <p:sp>
+        <p:nvSpPr>
+          <p:cNvPr id="2133676661" name="Google Shape;105;g393f66bba02_1_6"/>
+          <p:cNvSpPr/>
+          <p:nvPr/>
+        </p:nvSpPr>
+        <p:spPr bwMode="auto">
+          <a:xfrm>
+            <a:off x="1496965" y="324857"/>
+            <a:ext cx="6824075" cy="923400"/>
+          </a:xfrm>
+          <a:prstGeom prst="rect">
+            <a:avLst/>
+          </a:prstGeom>
+          <a:noFill/>
+          <a:ln>
+            <a:noFill/>
+          </a:ln>
+        </p:spPr>
+        <p:txBody>
+          <a:bodyPr spcFirstLastPara="1" wrap="square" lIns="91425" tIns="45700" rIns="91425" bIns="45700" anchor="t" anchorCtr="0">
+            <a:noAutofit/>
+            <a:noAutofit/>
+          </a:bodyPr>
+          <a:lstStyle/>
+          <a:p>
+            <a:pPr lvl="0">
+              <a:defRPr/>
+            </a:pPr>
+            <a:r>
+              <a:rPr lang="es-CO" sz="3200" b="1">
+                <a:solidFill>
+                  <a:schemeClr val="bg1"/>
+                </a:solidFill>
+                <a:latin typeface="Calibri"/>
+                <a:ea typeface="Calibri"/>
+                <a:cs typeface="Calibri"/>
+              </a:rPr>
+              <a:t>Objetivo del proyecto</a:t>
+            </a:r>
+            <a:endParaRPr lang="es-CO" sz="3200" b="1" i="0" u="none" strike="noStrike" cap="none">
+              <a:solidFill>
+                <a:schemeClr val="bg1"/>
+              </a:solidFill>
+              <a:latin typeface="Calibri"/>
+              <a:ea typeface="Calibri"/>
+              <a:cs typeface="Calibri"/>
+            </a:endParaRPr>
+          </a:p>
+        </p:txBody>
+      </p:sp>
+      <p:sp>
+        <p:nvSpPr>
+          <p:cNvPr id="2133676662" name="E2-Obj-Cuerpo"/>
+          <p:cNvSpPr txBox="1"/>
+          <p:nvPr/>
+        </p:nvSpPr>
+        <p:spPr bwMode="auto">
+          <a:xfrm>
+            <a:off x="685800" y="2463393"/>
+            <a:ext cx="10442448" cy="4120286"/>
+          </a:xfrm>
+          <a:prstGeom prst="rect">
+            <a:avLst/>
+          </a:prstGeom>
+          <a:noFill/>
+        </p:spPr>
+        <p:txBody>
+          <a:bodyPr rot="0" spcFirstLastPara="0" vertOverflow="overflow" horzOverflow="overflow" vert="horz" wrap="square" lIns="91440" tIns="45720" rIns="91440" bIns="45720" numCol="1" spcCol="0" rtlCol="0" fromWordArt="0" anchor="t" anchorCtr="0" forceAA="0" compatLnSpc="1">
+            <a:prstTxWarp prst="textNoShape"/>
+            <a:spAutoFit/>
+          </a:bodyPr>
+          <a:lstStyle/>
+          <a:p>
+            <a:pPr lvl="1" marL="742950" indent="-285750">
+              <a:buFont typeface="Courier New"/>
+              <a:buChar char="o"/>
+            </a:pPr>
+            <a:r>
+              <a:rPr lang="es-ES" dirty="0" sz="1800" b="1"/>
+              <a:t>Objetivo general: </a:t>
+            </a:r>
+            <a:r>
+              <a:rPr lang="es-ES" dirty="0" sz="1800"/>
+              <a:t>desarrollar un sistema de PLN que apoye el análisis y la consulta de las sentencias de la Corte Constitucional de Colombia (1992-2021), con cuatro componentes: validar la providencia, clasificar su área temática constitucional, identificar los artículos de la Constitución que la sustentan y situarla en su contexto jurisprudencial.</a:t>
+            </a:r>
+          </a:p>
+          <a:p>
+            <a:pPr lvl="1" marL="742950" indent="-285750">
+              <a:buFont typeface="Courier New"/>
+              <a:buChar char="o"/>
+            </a:pPr>
+            <a:r>
+              <a:rPr lang="es-ES" dirty="0" sz="1800" b="1"/>
+              <a:t>Caracterizar el corpus: </a:t>
+            </a:r>
+            <a:r>
+              <a:rPr lang="es-ES" dirty="0" sz="1800"/>
+              <a:t>textometría, morfología, diversidad léxica y evolución temporal.</a:t>
+            </a:r>
+          </a:p>
+          <a:p>
+            <a:pPr lvl="1" marL="742950" indent="-285750">
+              <a:buFont typeface="Courier New"/>
+              <a:buChar char="o"/>
+            </a:pPr>
+            <a:r>
+              <a:rPr lang="es-ES" dirty="0" sz="1800" b="1"/>
+              <a:t>Construir un conjunto de datos medido: </a:t>
+            </a:r>
+            <a:r>
+              <a:rPr lang="es-ES" dirty="0" sz="1800"/>
+              <a:t>23.742 sentencias con métricas por documento, reproducible y documentado.</a:t>
+            </a:r>
+          </a:p>
+          <a:p>
+            <a:pPr lvl="1" marL="742950" indent="-285750">
+              <a:buFont typeface="Courier New"/>
+              <a:buChar char="o"/>
+            </a:pPr>
+            <a:r>
+              <a:rPr lang="es-ES" dirty="0" sz="1800" b="1"/>
+              <a:t>Definir y justificar la representación: </a:t>
+            </a:r>
+            <a:r>
+              <a:rPr lang="es-ES" dirty="0" sz="1800"/>
+              <a:t>TF-IDF sobre lemas como representación principal; embeddings como línea comparativa.</a:t>
+            </a:r>
+          </a:p>
+          <a:p>
+            <a:pPr lvl="1" marL="742950" indent="-285750">
+              <a:buFont typeface="Courier New"/>
+              <a:buChar char="o"/>
+            </a:pPr>
+            <a:r>
+              <a:rPr lang="es-ES" dirty="0" sz="1800" b="1"/>
+              <a:t>Proponer la metodología: </a:t>
+            </a:r>
+            <a:r>
+              <a:rPr lang="es-ES" dirty="0" sz="1800"/>
+              <a:t>clasificación por área temática y tipo de providencia como primera etapa del sistema, con criterios de evaluación y anti-leakage; el vínculo con los artículos de la Constitución y el contexto jurisprudencial se abordan como trabajo futuro.</a:t>
+            </a:r>
+          </a:p>
+        </p:txBody>
+      </p:sp>
+      <p:sp>
+        <p:nvSpPr>
+          <p:cNvPr id="2133676663" name="TextBox 7"/>
+          <p:cNvSpPr txBox="1"/>
+          <p:nvPr/>
+        </p:nvSpPr>
+        <p:spPr bwMode="auto">
+          <a:xfrm>
+            <a:off x="2127647" y="1609925"/>
+            <a:ext cx="8896906" cy="523220"/>
+          </a:xfrm>
+          <a:prstGeom prst="rect">
+            <a:avLst/>
+          </a:prstGeom>
+          <a:noFill/>
+        </p:spPr>
+        <p:txBody>
+          <a:bodyPr rot="0" spcFirstLastPara="0" vertOverflow="overflow" horzOverflow="overflow" vert="horz" wrap="square" lIns="91440" tIns="45720" rIns="91440" bIns="45720" numCol="1" spcCol="0" rtlCol="0" fromWordArt="0" anchor="t" anchorCtr="0" forceAA="0" compatLnSpc="1">
+            <a:prstTxWarp prst="textNoShape"/>
+            <a:spAutoFit/>
+          </a:bodyPr>
+          <a:lstStyle/>
+          <a:p>
+            <a:pPr>
+              <a:defRPr/>
+            </a:pPr>
+            <a:r>
+              <a:rPr lang="es-CO" sz="2800" b="1">
+                <a:solidFill>
+                  <a:schemeClr val="accent4">
+                    <a:lumMod val="60000"/>
+                    <a:lumOff val="40000"/>
+                  </a:schemeClr>
+                </a:solidFill>
+                <a:ea typeface="Calibri"/>
+              </a:rPr>
+              <a:t>General y objetivos específicos</a:t>
+            </a:r>
+            <a:endParaRPr/>
+          </a:p>
+        </p:txBody>
+      </p:sp>
+      <p:pic>
+        <p:nvPicPr>
+          <p:cNvPr id="2133676664" name="Imagen 2"/>
+          <p:cNvPicPr>
+            <a:picLocks noChangeAspect="1"/>
+          </p:cNvPicPr>
+          <p:nvPr/>
+        </p:nvPicPr>
+        <p:blipFill rotWithShape="1">
+          <a:blip r:embed="rId3">
+            <a:duotone>
+              <a:schemeClr val="accent5">
+                <a:shade val="45000"/>
+                <a:satMod val="135000"/>
+              </a:schemeClr>
+              <a:prstClr val="white"/>
+            </a:duotone>
+          </a:blip>
+          <a:stretch/>
+        </p:blipFill>
+        <p:spPr bwMode="auto">
+          <a:xfrm>
+            <a:off x="1227647" y="1426521"/>
+            <a:ext cx="900000" cy="900000"/>
+          </a:xfrm>
+          <a:prstGeom prst="rect">
+            <a:avLst/>
+          </a:prstGeom>
+        </p:spPr>
+      </p:pic>
+    </p:spTree>
+  </p:cSld>
+  <p:clrMapOvr>
+    <a:masterClrMapping/>
+  </p:clrMapOvr>
+</p:sld>
+</file>
+
+<file path=ppt/slides/slide38.xml><?xml version="1.0" encoding="utf-8"?>
+<p:sld xmlns:a="http://schemas.openxmlformats.org/drawingml/2006/main" xmlns:p="http://schemas.openxmlformats.org/presentationml/2006/main" xmlns:r="http://schemas.openxmlformats.org/officeDocument/2006/relationships">
+  <p:cSld>
+    <p:spTree>
+      <p:nvGrpSpPr>
+        <p:cNvPr id="2133676719" name=""/>
+        <p:cNvGrpSpPr/>
+        <p:nvPr/>
+      </p:nvGrpSpPr>
+      <p:grpSpPr/>
+      <p:pic>
+        <p:nvPicPr>
+          <p:cNvPr id="2133676720" name="Google Shape;104;g393f66bba02_1_6"/>
+          <p:cNvPicPr/>
+          <p:nvPr/>
+        </p:nvPicPr>
+        <p:blipFill rotWithShape="1">
+          <a:blip r:embed="rId2">
+            <a:alphaModFix/>
+          </a:blip>
+          <a:stretch/>
+        </p:blipFill>
+        <p:spPr bwMode="auto">
+          <a:xfrm>
+            <a:off x="-1" y="0"/>
+            <a:ext cx="12192004" cy="1623060"/>
+          </a:xfrm>
+          <a:prstGeom prst="rect">
+            <a:avLst/>
+          </a:prstGeom>
+          <a:noFill/>
+          <a:ln>
+            <a:noFill/>
+          </a:ln>
+        </p:spPr>
+      </p:pic>
+      <p:sp>
+        <p:nvSpPr>
+          <p:cNvPr id="2133676721" name="Google Shape;105;g393f66bba02_1_6"/>
+          <p:cNvSpPr/>
+          <p:nvPr/>
+        </p:nvSpPr>
+        <p:spPr bwMode="auto">
+          <a:xfrm>
+            <a:off x="1496965" y="324857"/>
+            <a:ext cx="6824075" cy="923400"/>
+          </a:xfrm>
+          <a:prstGeom prst="rect">
+            <a:avLst/>
+          </a:prstGeom>
+          <a:noFill/>
+          <a:ln>
+            <a:noFill/>
+          </a:ln>
+        </p:spPr>
+        <p:txBody>
+          <a:bodyPr spcFirstLastPara="1" wrap="square" lIns="91425" tIns="45700" rIns="91425" bIns="45700" anchor="t" anchorCtr="0">
+            <a:noAutofit/>
+            <a:noAutofit/>
+          </a:bodyPr>
+          <a:lstStyle/>
+          <a:p>
+            <a:pPr lvl="0">
+              <a:defRPr/>
+            </a:pPr>
+            <a:r>
+              <a:rPr lang="es-CO" sz="3200" b="1">
+                <a:solidFill>
+                  <a:schemeClr val="bg1"/>
+                </a:solidFill>
+                <a:latin typeface="Calibri"/>
+                <a:ea typeface="Calibri"/>
+                <a:cs typeface="Calibri"/>
+              </a:rPr>
+              <a:t>Trabajos futuros</a:t>
+            </a:r>
+            <a:endParaRPr lang="es-CO" sz="3200" b="1" i="0" u="none" strike="noStrike" cap="none">
+              <a:solidFill>
+                <a:schemeClr val="bg1"/>
+              </a:solidFill>
+              <a:latin typeface="Calibri"/>
+              <a:ea typeface="Calibri"/>
+              <a:cs typeface="Calibri"/>
+            </a:endParaRPr>
+          </a:p>
+        </p:txBody>
+      </p:sp>
+      <p:sp>
+        <p:nvSpPr>
+          <p:cNvPr id="2133676722" name="E2-Fut-Cuerpo"/>
+          <p:cNvSpPr txBox="1"/>
+          <p:nvPr/>
+        </p:nvSpPr>
+        <p:spPr bwMode="auto">
+          <a:xfrm>
+            <a:off x="685800" y="2463393"/>
+            <a:ext cx="10442448" cy="4120286"/>
+          </a:xfrm>
+          <a:prstGeom prst="rect">
+            <a:avLst/>
+          </a:prstGeom>
+          <a:noFill/>
+        </p:spPr>
+        <p:txBody>
+          <a:bodyPr rot="0" spcFirstLastPara="0" vertOverflow="overflow" horzOverflow="overflow" vert="horz" wrap="square" lIns="91440" tIns="45720" rIns="91440" bIns="45720" numCol="1" spcCol="0" rtlCol="0" fromWordArt="0" anchor="t" anchorCtr="0" forceAA="0" compatLnSpc="1">
+            <a:prstTxWarp prst="textNoShape"/>
+            <a:spAutoFit/>
+          </a:bodyPr>
+          <a:lstStyle/>
+          <a:p>
+            <a:pPr lvl="1" marL="742950" indent="-285750">
+              <a:buFont typeface="Courier New"/>
+              <a:buChar char="o"/>
+            </a:pPr>
+            <a:r>
+              <a:rPr lang="es-ES" dirty="0" sz="1800" b="1"/>
+              <a:t>Etiquetas de referencia: </a:t>
+            </a:r>
+            <a:r>
+              <a:rPr lang="es-ES" dirty="0" sz="1800"/>
+              <a:t>validación humana progresiva de las etiquetas automáticas mediante anotación experta, hasta consolidar un estándar de referencia.</a:t>
+            </a:r>
+          </a:p>
+          <a:p>
+            <a:pPr lvl="1" marL="1028700"/>
+            <a:r>
+              <a:rPr lang="es-ES" dirty="0" sz="1100" i="1">
+                <a:solidFill>
+                  <a:srgbClr val="425466"/>
+                </a:solidFill>
+              </a:rPr>
+              <a:t>Herramientas: etiquetado débil por citas a la Constitución y EuroVoc; auditoría con cleanlab; preanotación con ALIA-7B-Instruct.</a:t>
+            </a:r>
+          </a:p>
+          <a:p>
+            <a:pPr lvl="1" marL="742950" indent="-285750">
+              <a:buFont typeface="Courier New"/>
+              <a:buChar char="o"/>
+            </a:pPr>
+            <a:r>
+              <a:rPr lang="es-ES" dirty="0" sz="1800" b="1"/>
+              <a:t>Modelado supervisado: </a:t>
+            </a:r>
+            <a:r>
+              <a:rPr lang="es-ES" dirty="0" sz="1800"/>
+              <a:t>modelos lineales frente a transformer con segmentación por fragmentos, calibración de umbrales y análisis de errores por periodo y tipo.</a:t>
+            </a:r>
+          </a:p>
+          <a:p>
+            <a:pPr lvl="1" marL="1028700"/>
+            <a:r>
+              <a:rPr lang="es-ES" dirty="0" sz="1100" i="1">
+                <a:solidFill>
+                  <a:srgbClr val="425466"/>
+                </a:solidFill>
+              </a:rPr>
+              <a:t>Herramientas: TF-IDF con regresión logística y SVM lineal (scikit-learn), LightGBM; ajuste eficiente con LoRA/PEFT.</a:t>
+            </a:r>
+          </a:p>
+          <a:p>
+            <a:pPr lvl="1" marL="742950" indent="-285750">
+              <a:buFont typeface="Courier New"/>
+              <a:buChar char="o"/>
+            </a:pPr>
+            <a:r>
+              <a:rPr lang="es-ES" dirty="0" sz="1800" b="1"/>
+              <a:t>Recuperación con modelos de lenguaje: </a:t>
+            </a:r>
+            <a:r>
+              <a:rPr lang="es-ES" dirty="0" sz="1800"/>
+              <a:t>búsqueda híbrida (léxica y densa) y reordenamiento de candidatos para vincular sentencia y artículos de la Constitución; evaluación con referencia graduada.</a:t>
+            </a:r>
+          </a:p>
+          <a:p>
+            <a:pPr lvl="1" marL="1028700"/>
+            <a:r>
+              <a:rPr lang="es-ES" dirty="0" sz="1100" i="1">
+                <a:solidFill>
+                  <a:srgbClr val="425466"/>
+                </a:solidFill>
+              </a:rPr>
+              <a:t>Herramientas: híbrida BM25 + embeddings E5, reranker cross-encoder y ALIA-7B-Instruct; grafo de citas como señal.</a:t>
+            </a:r>
+          </a:p>
+          <a:p>
+            <a:pPr lvl="1" marL="742950" indent="-285750">
+              <a:buFont typeface="Courier New"/>
+              <a:buChar char="o"/>
+            </a:pPr>
+            <a:r>
+              <a:rPr lang="es-ES" dirty="0" sz="1800" b="1"/>
+              <a:t>Representaciones contextuales: </a:t>
+            </a:r>
+            <a:r>
+              <a:rPr lang="es-ES" dirty="0" sz="1800"/>
+              <a:t>embeddings de dominio legal y agregación por fragmentos como complemento de TF-IDF.</a:t>
+            </a:r>
+          </a:p>
+          <a:p>
+            <a:pPr lvl="1" marL="1028700"/>
+            <a:r>
+              <a:rPr lang="es-ES" dirty="0" sz="1100" i="1">
+                <a:solidFill>
+                  <a:srgbClr val="425466"/>
+                </a:solidFill>
+              </a:rPr>
+              <a:t>Herramientas: multilingual-e5-base, BETO por documento y por fragmentos; variantes legales (ALIA-MrBERT, BGE-M3, ModernBERT legal).</a:t>
+            </a:r>
+          </a:p>
+          <a:p>
+            <a:pPr lvl="1" marL="742950" indent="-285750">
+              <a:buFont typeface="Courier New"/>
+              <a:buChar char="o"/>
+            </a:pPr>
+            <a:r>
+              <a:rPr lang="es-ES" dirty="0" sz="1800" b="1"/>
+              <a:t>Aplicaciones: </a:t>
+            </a:r>
+            <a:r>
+              <a:rPr lang="es-ES" dirty="0" sz="1800"/>
+              <a:t>resumen de sentencias extensas, contexto jurisprudencial (red de precedentes) y análisis diacrónico del vocabulario.</a:t>
+            </a:r>
+          </a:p>
+          <a:p>
+            <a:pPr lvl="1" marL="1028700"/>
+            <a:r>
+              <a:rPr lang="es-ES" dirty="0" sz="1100" i="1">
+                <a:solidFill>
+                  <a:srgbClr val="425466"/>
+                </a:solidFill>
+              </a:rPr>
+              <a:t>Herramientas: resumen y consulta con ALIA-7B-Instruct; contexto jurisprudencial con retrieval y grafo de citas; diacronía con embeddings.</a:t>
+            </a:r>
+          </a:p>
+        </p:txBody>
+      </p:sp>
+      <p:sp>
+        <p:nvSpPr>
+          <p:cNvPr id="2133676723" name="TextBox 7"/>
+          <p:cNvSpPr txBox="1"/>
+          <p:nvPr/>
+        </p:nvSpPr>
+        <p:spPr bwMode="auto">
+          <a:xfrm>
+            <a:off x="2127647" y="1609925"/>
+            <a:ext cx="8896906" cy="523220"/>
+          </a:xfrm>
+          <a:prstGeom prst="rect">
+            <a:avLst/>
+          </a:prstGeom>
+          <a:noFill/>
+        </p:spPr>
+        <p:txBody>
+          <a:bodyPr rot="0" spcFirstLastPara="0" vertOverflow="overflow" horzOverflow="overflow" vert="horz" wrap="square" lIns="91440" tIns="45720" rIns="91440" bIns="45720" numCol="1" spcCol="0" rtlCol="0" fromWordArt="0" anchor="t" anchorCtr="0" forceAA="0" compatLnSpc="1">
+            <a:prstTxWarp prst="textNoShape"/>
+            <a:spAutoFit/>
+          </a:bodyPr>
+          <a:lstStyle/>
+          <a:p>
+            <a:pPr>
+              <a:defRPr/>
+            </a:pPr>
+            <a:r>
+              <a:rPr lang="es-CO" sz="2800" b="1">
+                <a:solidFill>
+                  <a:schemeClr val="accent4">
+                    <a:lumMod val="60000"/>
+                    <a:lumOff val="40000"/>
+                  </a:schemeClr>
+                </a:solidFill>
+                <a:ea typeface="Calibri"/>
+              </a:rPr>
+              <a:t>Del corpus medido a las aplicaciones</a:t>
+            </a:r>
+            <a:endParaRPr/>
+          </a:p>
+        </p:txBody>
+      </p:sp>
+      <p:pic>
+        <p:nvPicPr>
+          <p:cNvPr id="2133676724" name="Imagen 2"/>
+          <p:cNvPicPr>
+            <a:picLocks noChangeAspect="1"/>
+          </p:cNvPicPr>
+          <p:nvPr/>
+        </p:nvPicPr>
+        <p:blipFill rotWithShape="1">
+          <a:blip r:embed="rId3">
+            <a:duotone>
+              <a:schemeClr val="accent5">
+                <a:shade val="45000"/>
+                <a:satMod val="135000"/>
+              </a:schemeClr>
+              <a:prstClr val="white"/>
+            </a:duotone>
+          </a:blip>
+          <a:stretch/>
+        </p:blipFill>
+        <p:spPr bwMode="auto">
+          <a:xfrm>
+            <a:off x="1227647" y="1426521"/>
+            <a:ext cx="900000" cy="900000"/>
+          </a:xfrm>
+          <a:prstGeom prst="rect">
+            <a:avLst/>
+          </a:prstGeom>
+        </p:spPr>
+      </p:pic>
+      <p:sp>
+        <p:nvSpPr>
+          <p:cNvPr id="2133676725" name="E2-Nota"/>
+          <p:cNvSpPr txBox="1"/>
+          <p:nvPr/>
+        </p:nvSpPr>
+        <p:spPr>
+          <a:xfrm>
+            <a:off x="786384" y="6492240"/>
+            <a:ext cx="10579608" cy="292608"/>
+          </a:xfrm>
+          <a:prstGeom prst="rect">
+            <a:avLst/>
+          </a:prstGeom>
+          <a:noFill/>
+        </p:spPr>
+        <p:txBody>
+          <a:bodyPr wrap="square">
+            <a:spAutoFit/>
+          </a:bodyPr>
+          <a:lstStyle/>
+          <a:p>
+            <a:pPr algn="ctr"/>
+            <a:r>
+              <a:rPr sz="1000" i="1" b="0">
+                <a:solidFill>
+                  <a:srgbClr val="425466"/>
+                </a:solidFill>
+                <a:latin typeface="Arial"/>
+              </a:rPr>
+              <a:t>Nota: varias de estas herramientas ya están implementadas en el avance del proyecto.</a:t>
+            </a:r>
           </a:p>
         </p:txBody>
       </p:sp>

</xml_diff>